<commit_message>
Ethic-AI 2 ad ampio respiro: filo filosofico-magisteriale e prompt etici
Approfondimento su Floridi, Fabris, Panai, Benanti e magistero (Rome
Call, Antiqua et Nova, Leone XIV) con capsule da 10' per incontro e
precisazione sull'assenza a oggi di un'enciclica sull'IA; scheda E7 con
la libreria dei prompt etici e di controllo; due nuove slide nei deck
(Bussola filosofica all'incontro 1, Prompt etici all'incontro 5).

Co-Authored-By: Claude Fable 5 <noreply@anthropic.com>
Claude-Session: https://claude.ai/code/session_0172uWTkaEwfthdZ7KpLdiL5
</commit_message>
<xml_diff>
--- a/progetto-snodi/corsi/ethic-ai-2/incontri/E01-impatto-sociale-ai-act.pptx
+++ b/progetto-snodi/corsi/ethic-ai-2/incontri/E01-impatto-sociale-ai-act.pptx
@@ -14,9 +14,10 @@
     <p:sldId id="262" r:id="rId8"/>
     <p:sldId id="263" r:id="rId9"/>
     <p:sldId id="264" r:id="rId10"/>
+    <p:sldId id="265" r:id="rId11"/>
   </p:sldIdLst>
   <p:notesMasterIdLst>
-    <p:notesMasterId r:id="rId11"/>
+    <p:notesMasterId r:id="rId12"/>
   </p:notesMasterIdLst>
   <p:sldSz cx="12188952" cy="6858000"/>
   <p:notesSz cx="6858000" cy="12188952"/>
@@ -552,6 +553,94 @@
 </p:notes>
 </file>
 
+<file path=ppt/notesSlides/notesSlide10.xml><?xml version="1.0" encoding="utf-8"?>
+<p:notes xmlns:a="http://schemas.openxmlformats.org/drawingml/2006/main" xmlns:r="http://schemas.openxmlformats.org/officeDocument/2006/relationships" xmlns:p="http://schemas.openxmlformats.org/presentationml/2006/main">
+  <p:cSld>
+    <p:spTree>
+      <p:nvGrpSpPr>
+        <p:cNvPr id="1" name=""/>
+        <p:cNvGrpSpPr/>
+        <p:nvPr/>
+      </p:nvGrpSpPr>
+      <p:grpSpPr>
+        <a:xfrm>
+          <a:off x="0" y="0"/>
+          <a:ext cx="0" cy="0"/>
+          <a:chOff x="0" y="0"/>
+          <a:chExt cx="0" cy="0"/>
+        </a:xfrm>
+      </p:grpSpPr>
+      <p:sp>
+        <p:nvSpPr>
+          <p:cNvPr id="2" name="Slide Image Placeholder 1"/>
+          <p:cNvSpPr>
+            <a:spLocks noGrp="1" noRot="1" noChangeAspect="1"/>
+          </p:cNvSpPr>
+          <p:nvPr>
+            <p:ph type="sldImg"/>
+          </p:nvPr>
+        </p:nvSpPr>
+        <p:spPr/>
+      </p:sp>
+      <p:sp>
+        <p:nvSpPr>
+          <p:cNvPr id="3" name="Notes Placeholder 2"/>
+          <p:cNvSpPr>
+            <a:spLocks noGrp="1"/>
+          </p:cNvSpPr>
+          <p:nvPr>
+            <p:ph type="body" idx="1"/>
+          </p:nvPr>
+        </p:nvSpPr>
+        <p:spPr/>
+        <p:txBody>
+          <a:bodyPr/>
+          <a:lstStyle/>
+          <a:p>
+            <a:r>
+              <a:rPr lang="en-US" dirty="0"/>
+              <a:t>Chiusura puntuale, firma registro. Il caso mediatico da portare è il materiale del prossimo laboratorio: insistere.</a:t>
+            </a:r>
+            <a:endParaRPr lang="en-US" dirty="0"/>
+          </a:p>
+        </p:txBody>
+      </p:sp>
+      <p:sp>
+        <p:nvSpPr>
+          <p:cNvPr id="4" name="Slide Number Placeholder 3"/>
+          <p:cNvSpPr>
+            <a:spLocks noGrp="1"/>
+          </p:cNvSpPr>
+          <p:nvPr>
+            <p:ph type="sldNum" sz="quarter" idx="10"/>
+          </p:nvPr>
+        </p:nvSpPr>
+        <p:spPr/>
+        <p:txBody>
+          <a:bodyPr/>
+          <a:lstStyle/>
+          <a:p>
+            <a:fld id="{F7021451-1387-4CA6-816F-3879F97B5CBC}" type="slidenum">
+              <a:rPr lang="en-US"/>
+              <a:t>10</a:t>
+            </a:fld>
+            <a:endParaRPr lang="en-US"/>
+          </a:p>
+        </p:txBody>
+      </p:sp>
+    </p:spTree>
+    <p:extLst>
+      <p:ext uri="{BB962C8B-B14F-4D97-AF65-F5344CB8AC3E}">
+        <p14:creationId xmlns:p14="http://schemas.microsoft.com/office/powerpoint/2010/main" val="1024086991"/>
+      </p:ext>
+    </p:extLst>
+  </p:cSld>
+  <p:clrMapOvr>
+    <a:masterClrMapping/>
+  </p:clrMapOvr>
+</p:notes>
+</file>
+
 <file path=ppt/notesSlides/notesSlide2.xml><?xml version="1.0" encoding="utf-8"?>
 <p:notes xmlns:a="http://schemas.openxmlformats.org/drawingml/2006/main" xmlns:r="http://schemas.openxmlformats.org/officeDocument/2006/relationships" xmlns:p="http://schemas.openxmlformats.org/presentationml/2006/main">
   <p:cSld>
@@ -1038,7 +1127,7 @@
           <a:p>
             <a:r>
               <a:rPr lang="en-US" dirty="0"/>
-              <a:t>Il laboratorio produce la materia prima delle UdA: ogni gruppo esce con un caso reale classificato. Girare nelle stanze e spingere verso casi vicini all'esperienza degli studenti, non casi da manuale.</a:t>
+              <a:t>La slide-mappa: ogni voce tornerà come 'capsula filosofica' da 10 minuti negli incontri successivi (Floridi qui, Fabris al 2, Antiqua et Nova al 3, Benanti al 4, Panai al 5). Precisione da tenere: NON esiste a oggi un'enciclica sull'IA — i documenti sono la nota Antiqua et Nova e il Rome Call; verificare prima del corso se nel frattempo è uscita (ed è essa stessa una lezione di fact-checking). Il registro è laico: si citano per la qualità concettuale, non per catechesi.</a:t>
             </a:r>
             <a:endParaRPr lang="en-US" dirty="0"/>
           </a:p>
@@ -1126,7 +1215,7 @@
           <a:p>
             <a:r>
               <a:rPr lang="en-US" dirty="0"/>
-              <a:t>Stessa slide-firma di Edu-GenAI 2: colloca il corso nell'agenda internazionale. L'EDPS va citato con l'ambito corretto (istituzioni UE) come modello di governance.</a:t>
+              <a:t>Il laboratorio produce la materia prima delle UdA: ogni gruppo esce con un caso reale classificato. Girare nelle stanze e spingere verso casi vicini all'esperienza degli studenti, non casi da manuale.</a:t>
             </a:r>
             <a:endParaRPr lang="en-US" dirty="0"/>
           </a:p>
@@ -1214,7 +1303,7 @@
           <a:p>
             <a:r>
               <a:rPr lang="en-US" dirty="0"/>
-              <a:t>Chiusura puntuale, firma registro. Il caso mediatico da portare è il materiale del prossimo laboratorio: insistere.</a:t>
+              <a:t>Stessa slide-firma di Edu-GenAI 2: colloca il corso nell'agenda internazionale. L'EDPS va citato con l'ambito corretto (istituzioni UE) come modello di governance.</a:t>
             </a:r>
             <a:endParaRPr lang="en-US" dirty="0"/>
           </a:p>
@@ -1871,6 +1960,263 @@
 </p:sld>
 </file>
 
+<file path=ppt/slides/slide10.xml><?xml version="1.0" encoding="utf-8"?>
+<p:sld xmlns:a="http://schemas.openxmlformats.org/drawingml/2006/main" xmlns:r="http://schemas.openxmlformats.org/officeDocument/2006/relationships" xmlns:p="http://schemas.openxmlformats.org/presentationml/2006/main">
+  <p:cSld name="Slide 10">
+    <p:bg>
+      <p:bgPr>
+        <a:solidFill>
+          <a:srgbClr val="1E2761"/>
+        </a:solidFill>
+      </p:bgPr>
+    </p:bg>
+    <p:spTree>
+      <p:nvGrpSpPr>
+        <p:cNvPr id="1" name=""/>
+        <p:cNvGrpSpPr/>
+        <p:nvPr/>
+      </p:nvGrpSpPr>
+      <p:grpSpPr>
+        <a:xfrm>
+          <a:off x="0" y="0"/>
+          <a:ext cx="0" cy="0"/>
+          <a:chOff x="0" y="0"/>
+          <a:chExt cx="0" cy="0"/>
+        </a:xfrm>
+      </p:grpSpPr>
+      <p:sp>
+        <p:nvSpPr>
+          <p:cNvPr id="2" name="Text 0"/>
+          <p:cNvSpPr/>
+          <p:nvPr/>
+        </p:nvSpPr>
+        <p:spPr>
+          <a:xfrm>
+            <a:off x="822960" y="731520"/>
+            <a:ext cx="10515600" cy="640080"/>
+          </a:xfrm>
+          <a:prstGeom prst="rect">
+            <a:avLst/>
+          </a:prstGeom>
+          <a:noFill/>
+          <a:ln/>
+        </p:spPr>
+        <p:txBody>
+          <a:bodyPr wrap="square" lIns="0" tIns="0" rIns="0" bIns="0" rtlCol="0" anchor="ctr"/>
+          <a:lstStyle/>
+          <a:p>
+            <a:pPr indent="0" marL="0">
+              <a:buNone/>
+            </a:pPr>
+            <a:r>
+              <a:rPr lang="en-US" sz="3400" b="1" dirty="0">
+                <a:solidFill>
+                  <a:srgbClr val="FFFFFF"/>
+                </a:solidFill>
+                <a:latin typeface="Cambria" pitchFamily="34" charset="0"/>
+                <a:ea typeface="Cambria" pitchFamily="34" charset="-122"/>
+                <a:cs typeface="Cambria" pitchFamily="34" charset="-120"/>
+              </a:rPr>
+              <a:t>Per il prossimo incontro</a:t>
+            </a:r>
+            <a:endParaRPr lang="en-US" sz="3400" dirty="0"/>
+          </a:p>
+        </p:txBody>
+      </p:sp>
+      <p:sp>
+        <p:nvSpPr>
+          <p:cNvPr id="3" name="Text 1"/>
+          <p:cNvSpPr/>
+          <p:nvPr/>
+        </p:nvSpPr>
+        <p:spPr>
+          <a:xfrm>
+            <a:off x="822960" y="1645920"/>
+            <a:ext cx="10515600" cy="3108960"/>
+          </a:xfrm>
+          <a:prstGeom prst="rect">
+            <a:avLst/>
+          </a:prstGeom>
+          <a:noFill/>
+          <a:ln/>
+        </p:spPr>
+        <p:txBody>
+          <a:bodyPr wrap="square" lIns="0" tIns="0" rIns="0" bIns="0" rtlCol="0" anchor="t"/>
+          <a:lstStyle/>
+          <a:p>
+            <a:pPr marL="177800" indent="-177800">
+              <a:spcAft>
+                <a:spcPts val="1000"/>
+              </a:spcAft>
+              <a:buSzPct val="100000"/>
+              <a:buChar char="•"/>
+            </a:pPr>
+            <a:r>
+              <a:rPr lang="en-US" sz="1600" dirty="0">
+                <a:solidFill>
+                  <a:srgbClr val="FFFFFF"/>
+                </a:solidFill>
+                <a:latin typeface="Calibri" pitchFamily="34" charset="0"/>
+                <a:ea typeface="Calibri" pitchFamily="34" charset="-122"/>
+                <a:cs typeface="Calibri" pitchFamily="34" charset="-120"/>
+              </a:rPr>
+              <a:t>Compilare il modulo dati partecipanti (indicatori PNRR — 5 minuti, in aula)</a:t>
+            </a:r>
+            <a:endParaRPr lang="en-US" sz="1600" dirty="0"/>
+          </a:p>
+          <a:p>
+            <a:pPr marL="177800" indent="-177800">
+              <a:spcAft>
+                <a:spcPts val="1000"/>
+              </a:spcAft>
+              <a:buSzPct val="100000"/>
+              <a:buChar char="•"/>
+            </a:pPr>
+            <a:r>
+              <a:rPr lang="en-US" sz="1600" dirty="0">
+                <a:solidFill>
+                  <a:srgbClr val="FFFFFF"/>
+                </a:solidFill>
+                <a:latin typeface="Calibri" pitchFamily="34" charset="0"/>
+                <a:ea typeface="Calibri" pitchFamily="34" charset="-122"/>
+                <a:cs typeface="Calibri" pitchFamily="34" charset="-120"/>
+              </a:rPr>
+              <a:t>Portare giovedì: un caso di decisione algoritmica trovato sui media (articolo, video, post) — lo useremo su DigComp 3.0</a:t>
+            </a:r>
+            <a:endParaRPr lang="en-US" sz="1600" dirty="0"/>
+          </a:p>
+          <a:p>
+            <a:pPr marL="177800" indent="-177800">
+              <a:spcAft>
+                <a:spcPts val="1000"/>
+              </a:spcAft>
+              <a:buSzPct val="100000"/>
+              <a:buChar char="•"/>
+            </a:pPr>
+            <a:r>
+              <a:rPr lang="en-US" sz="1600" dirty="0">
+                <a:solidFill>
+                  <a:srgbClr val="FFFFFF"/>
+                </a:solidFill>
+                <a:latin typeface="Calibri" pitchFamily="34" charset="0"/>
+                <a:ea typeface="Calibri" pitchFamily="34" charset="-122"/>
+                <a:cs typeface="Calibri" pitchFamily="34" charset="-120"/>
+              </a:rPr>
+              <a:t>Facoltativo: primi capitoli di O'Neil, 'Armi di distruzione matematica' (i casi si leggono come racconti)</a:t>
+            </a:r>
+            <a:endParaRPr lang="en-US" sz="1600" dirty="0"/>
+          </a:p>
+          <a:p>
+            <a:pPr marL="177800" indent="-177800">
+              <a:spcAft>
+                <a:spcPts val="1000"/>
+              </a:spcAft>
+              <a:buSzPct val="100000"/>
+              <a:buChar char="•"/>
+            </a:pPr>
+            <a:r>
+              <a:rPr lang="en-US" sz="1600" dirty="0">
+                <a:solidFill>
+                  <a:srgbClr val="FFFFFF"/>
+                </a:solidFill>
+                <a:latin typeface="Calibri" pitchFamily="34" charset="0"/>
+                <a:ea typeface="Calibri" pitchFamily="34" charset="-122"/>
+                <a:cs typeface="Calibri" pitchFamily="34" charset="-120"/>
+              </a:rPr>
+              <a:t>Chi non viene da Edu-GenAI 2: guida rapida all'ambiente protetto nel Drive del corso</a:t>
+            </a:r>
+            <a:endParaRPr lang="en-US" sz="1600" dirty="0"/>
+          </a:p>
+        </p:txBody>
+      </p:sp>
+      <p:sp>
+        <p:nvSpPr>
+          <p:cNvPr id="4" name="Shape 2"/>
+          <p:cNvSpPr/>
+          <p:nvPr/>
+        </p:nvSpPr>
+        <p:spPr>
+          <a:xfrm>
+            <a:off x="822960" y="4937760"/>
+            <a:ext cx="10515600" cy="1188720"/>
+          </a:xfrm>
+          <a:prstGeom prst="roundRect">
+            <a:avLst>
+              <a:gd name="adj" fmla="val 6923"/>
+            </a:avLst>
+          </a:prstGeom>
+          <a:solidFill>
+            <a:srgbClr val="CADCFC"/>
+          </a:solidFill>
+          <a:ln w="12700">
+            <a:solidFill>
+              <a:srgbClr val="CADCFC"/>
+            </a:solidFill>
+            <a:prstDash val="solid"/>
+          </a:ln>
+        </p:spPr>
+      </p:sp>
+      <p:sp>
+        <p:nvSpPr>
+          <p:cNvPr id="5" name="Text 3"/>
+          <p:cNvSpPr/>
+          <p:nvPr/>
+        </p:nvSpPr>
+        <p:spPr>
+          <a:xfrm>
+            <a:off x="1097280" y="4937760"/>
+            <a:ext cx="9966960" cy="1188720"/>
+          </a:xfrm>
+          <a:prstGeom prst="rect">
+            <a:avLst/>
+          </a:prstGeom>
+          <a:noFill/>
+          <a:ln/>
+        </p:spPr>
+        <p:txBody>
+          <a:bodyPr wrap="square" lIns="0" tIns="0" rIns="0" bIns="0" rtlCol="0" anchor="ctr"/>
+          <a:lstStyle/>
+          <a:p>
+            <a:pPr indent="0" marL="0">
+              <a:buNone/>
+            </a:pPr>
+            <a:r>
+              <a:rPr lang="en-US" sz="1600" b="1" dirty="0">
+                <a:solidFill>
+                  <a:srgbClr val="1E2761"/>
+                </a:solidFill>
+                <a:latin typeface="Cambria" pitchFamily="34" charset="0"/>
+                <a:ea typeface="Cambria" pitchFamily="34" charset="-122"/>
+                <a:cs typeface="Cambria" pitchFamily="34" charset="-120"/>
+              </a:rPr>
+              <a:t>Incontro 2 — giovedì 1 ottobre:  </a:t>
+            </a:r>
+            <a:pPr indent="0" marL="0">
+              <a:buNone/>
+            </a:pPr>
+            <a:r>
+              <a:rPr lang="en-US" sz="1400" dirty="0">
+                <a:solidFill>
+                  <a:srgbClr val="26303B"/>
+                </a:solidFill>
+                <a:latin typeface="Calibri" pitchFamily="34" charset="0"/>
+                <a:ea typeface="Calibri" pitchFamily="34" charset="-122"/>
+                <a:cs typeface="Calibri" pitchFamily="34" charset="-120"/>
+              </a:rPr>
+              <a:t>Cittadinanza democratica e DigComp 3.0: il nuovo quadro europeo, la sostenibilità del digitale e il benessere online.</a:t>
+            </a:r>
+            <a:endParaRPr lang="en-US" sz="1600" dirty="0"/>
+          </a:p>
+        </p:txBody>
+      </p:sp>
+    </p:spTree>
+  </p:cSld>
+  <p:clrMapOvr>
+    <a:masterClrMapping/>
+  </p:clrMapOvr>
+</p:sld>
+</file>
+
 <file path=ppt/slides/slide2.xml><?xml version="1.0" encoding="utf-8"?>
 <p:sld xmlns:a="http://schemas.openxmlformats.org/drawingml/2006/main" xmlns:r="http://schemas.openxmlformats.org/officeDocument/2006/relationships" xmlns:p="http://schemas.openxmlformats.org/presentationml/2006/main">
   <p:cSld name="Slide 2">
@@ -4947,7 +5293,7 @@
                 <a:ea typeface="Calibri" pitchFamily="34" charset="-122"/>
                 <a:cs typeface="Calibri" pitchFamily="34" charset="-120"/>
               </a:rPr>
-              <a:t>Esercitazione — mani sulla tastiera</a:t>
+              <a:t>Ethic-AI 2 — Etica, Bias e Cittadinanza nell'era dell'IA</a:t>
             </a:r>
             <a:endParaRPr lang="en-US" sz="1100" dirty="0"/>
           </a:p>
@@ -4986,7 +5332,7 @@
                 <a:ea typeface="Cambria" pitchFamily="34" charset="-122"/>
                 <a:cs typeface="Cambria" pitchFamily="34" charset="-120"/>
               </a:rPr>
-              <a:t>Laboratorio: la mappa degli impatti</a:t>
+              <a:t>La bussola filosofica del corso</a:t>
             </a:r>
             <a:endParaRPr lang="en-US" sz="3000" dirty="0"/>
           </a:p>
@@ -4994,105 +5340,14 @@
       </p:sp>
       <p:sp>
         <p:nvSpPr>
-          <p:cNvPr id="6" name="Shape 4"/>
+          <p:cNvPr id="6" name="Text 4"/>
           <p:cNvSpPr/>
           <p:nvPr/>
         </p:nvSpPr>
         <p:spPr>
           <a:xfrm>
             <a:off x="822960" y="1600200"/>
-            <a:ext cx="7315200" cy="4572000"/>
-          </a:xfrm>
-          <a:prstGeom prst="roundRect">
-            <a:avLst>
-              <a:gd name="adj" fmla="val 1800"/>
-            </a:avLst>
-          </a:prstGeom>
-          <a:solidFill>
-            <a:srgbClr val="E9F1FB"/>
-          </a:solidFill>
-          <a:ln w="12700">
-            <a:solidFill>
-              <a:srgbClr val="E9F1FB"/>
-            </a:solidFill>
-            <a:prstDash val="solid"/>
-          </a:ln>
-        </p:spPr>
-      </p:sp>
-      <p:sp>
-        <p:nvSpPr>
-          <p:cNvPr id="7" name="Shape 5"/>
-          <p:cNvSpPr/>
-          <p:nvPr/>
-        </p:nvSpPr>
-        <p:spPr>
-          <a:xfrm>
-            <a:off x="1051560" y="1828800"/>
-            <a:ext cx="384048" cy="384048"/>
-          </a:xfrm>
-          <a:prstGeom prst="ellipse">
-            <a:avLst/>
-          </a:prstGeom>
-          <a:solidFill>
-            <a:srgbClr val="1E2761"/>
-          </a:solidFill>
-          <a:ln w="12700">
-            <a:solidFill>
-              <a:srgbClr val="1E2761"/>
-            </a:solidFill>
-            <a:prstDash val="solid"/>
-          </a:ln>
-        </p:spPr>
-      </p:sp>
-      <p:sp>
-        <p:nvSpPr>
-          <p:cNvPr id="8" name="Text 6"/>
-          <p:cNvSpPr/>
-          <p:nvPr/>
-        </p:nvSpPr>
-        <p:spPr>
-          <a:xfrm>
-            <a:off x="1051560" y="1828800"/>
-            <a:ext cx="384048" cy="384048"/>
-          </a:xfrm>
-          <a:prstGeom prst="rect">
-            <a:avLst/>
-          </a:prstGeom>
-          <a:noFill/>
-          <a:ln/>
-        </p:spPr>
-        <p:txBody>
-          <a:bodyPr wrap="square" lIns="0" tIns="0" rIns="0" bIns="0" rtlCol="0" anchor="ctr"/>
-          <a:lstStyle/>
-          <a:p>
-            <a:pPr algn="ctr" indent="0" marL="0">
-              <a:buNone/>
-            </a:pPr>
-            <a:r>
-              <a:rPr lang="en-US" sz="1300" b="1" dirty="0">
-                <a:solidFill>
-                  <a:srgbClr val="FFFFFF"/>
-                </a:solidFill>
-                <a:latin typeface="Cambria" pitchFamily="34" charset="0"/>
-                <a:ea typeface="Cambria" pitchFamily="34" charset="-122"/>
-                <a:cs typeface="Cambria" pitchFamily="34" charset="-120"/>
-              </a:rPr>
-              <a:t>1</a:t>
-            </a:r>
-            <a:endParaRPr lang="en-US" sz="1300" dirty="0"/>
-          </a:p>
-        </p:txBody>
-      </p:sp>
-      <p:sp>
-        <p:nvSpPr>
-          <p:cNvPr id="9" name="Text 7"/>
-          <p:cNvSpPr/>
-          <p:nvPr/>
-        </p:nvSpPr>
-        <p:spPr>
-          <a:xfrm>
-            <a:off x="1600200" y="1783080"/>
-            <a:ext cx="6309360" cy="777240"/>
+            <a:ext cx="10515600" cy="4754880"/>
           </a:xfrm>
           <a:prstGeom prst="rect">
             <a:avLst/>
@@ -5104,532 +5359,15 @@
           <a:bodyPr wrap="square" lIns="0" tIns="0" rIns="0" bIns="0" rtlCol="0" anchor="t"/>
           <a:lstStyle/>
           <a:p>
-            <a:pPr indent="0" marL="0">
-              <a:buNone/>
-            </a:pPr>
-            <a:r>
-              <a:rPr lang="en-US" sz="1350" dirty="0">
-                <a:solidFill>
-                  <a:srgbClr val="26303B"/>
-                </a:solidFill>
-                <a:latin typeface="Calibri" pitchFamily="34" charset="0"/>
-                <a:ea typeface="Calibri" pitchFamily="34" charset="-122"/>
-                <a:cs typeface="Calibri" pitchFamily="34" charset="-120"/>
-              </a:rPr>
-              <a:t>In gruppi di 3-4 (stanze Meet): elencate i punti in cui un algoritmo tocca OGGI la vita dei vostri studenti (social, gaming, ricerche, acquisti, futuro lavoro)</a:t>
-            </a:r>
-            <a:endParaRPr lang="en-US" sz="1350" dirty="0"/>
-          </a:p>
-        </p:txBody>
-      </p:sp>
-      <p:sp>
-        <p:nvSpPr>
-          <p:cNvPr id="10" name="Shape 8"/>
-          <p:cNvSpPr/>
-          <p:nvPr/>
-        </p:nvSpPr>
-        <p:spPr>
-          <a:xfrm>
-            <a:off x="1051560" y="2670048"/>
-            <a:ext cx="384048" cy="384048"/>
-          </a:xfrm>
-          <a:prstGeom prst="ellipse">
-            <a:avLst/>
-          </a:prstGeom>
-          <a:solidFill>
-            <a:srgbClr val="1E2761"/>
-          </a:solidFill>
-          <a:ln w="12700">
-            <a:solidFill>
-              <a:srgbClr val="1E2761"/>
-            </a:solidFill>
-            <a:prstDash val="solid"/>
-          </a:ln>
-        </p:spPr>
-      </p:sp>
-      <p:sp>
-        <p:nvSpPr>
-          <p:cNvPr id="11" name="Text 9"/>
-          <p:cNvSpPr/>
-          <p:nvPr/>
-        </p:nvSpPr>
-        <p:spPr>
-          <a:xfrm>
-            <a:off x="1051560" y="2670048"/>
-            <a:ext cx="384048" cy="384048"/>
-          </a:xfrm>
-          <a:prstGeom prst="rect">
-            <a:avLst/>
-          </a:prstGeom>
-          <a:noFill/>
-          <a:ln/>
-        </p:spPr>
-        <p:txBody>
-          <a:bodyPr wrap="square" lIns="0" tIns="0" rIns="0" bIns="0" rtlCol="0" anchor="ctr"/>
-          <a:lstStyle/>
-          <a:p>
-            <a:pPr algn="ctr" indent="0" marL="0">
-              <a:buNone/>
-            </a:pPr>
-            <a:r>
-              <a:rPr lang="en-US" sz="1300" b="1" dirty="0">
-                <a:solidFill>
-                  <a:srgbClr val="FFFFFF"/>
-                </a:solidFill>
-                <a:latin typeface="Cambria" pitchFamily="34" charset="0"/>
-                <a:ea typeface="Cambria" pitchFamily="34" charset="-122"/>
-                <a:cs typeface="Cambria" pitchFamily="34" charset="-120"/>
-              </a:rPr>
-              <a:t>2</a:t>
-            </a:r>
-            <a:endParaRPr lang="en-US" sz="1300" dirty="0"/>
-          </a:p>
-        </p:txBody>
-      </p:sp>
-      <p:sp>
-        <p:nvSpPr>
-          <p:cNvPr id="12" name="Text 10"/>
-          <p:cNvSpPr/>
-          <p:nvPr/>
-        </p:nvSpPr>
-        <p:spPr>
-          <a:xfrm>
-            <a:off x="1600200" y="2624328"/>
-            <a:ext cx="6309360" cy="777240"/>
-          </a:xfrm>
-          <a:prstGeom prst="rect">
-            <a:avLst/>
-          </a:prstGeom>
-          <a:noFill/>
-          <a:ln/>
-        </p:spPr>
-        <p:txBody>
-          <a:bodyPr wrap="square" lIns="0" tIns="0" rIns="0" bIns="0" rtlCol="0" anchor="t"/>
-          <a:lstStyle/>
-          <a:p>
-            <a:pPr indent="0" marL="0">
-              <a:buNone/>
-            </a:pPr>
-            <a:r>
-              <a:rPr lang="en-US" sz="1350" dirty="0">
-                <a:solidFill>
-                  <a:srgbClr val="26303B"/>
-                </a:solidFill>
-                <a:latin typeface="Calibri" pitchFamily="34" charset="0"/>
-                <a:ea typeface="Calibri" pitchFamily="34" charset="-122"/>
-                <a:cs typeface="Calibri" pitchFamily="34" charset="-120"/>
-              </a:rPr>
-              <a:t>Per ciascun punto: chi decide cosa? Con quali dati? Lo studente lo sa?</a:t>
-            </a:r>
-            <a:endParaRPr lang="en-US" sz="1350" dirty="0"/>
-          </a:p>
-        </p:txBody>
-      </p:sp>
-      <p:sp>
-        <p:nvSpPr>
-          <p:cNvPr id="13" name="Shape 11"/>
-          <p:cNvSpPr/>
-          <p:nvPr/>
-        </p:nvSpPr>
-        <p:spPr>
-          <a:xfrm>
-            <a:off x="1051560" y="3511296"/>
-            <a:ext cx="384048" cy="384048"/>
-          </a:xfrm>
-          <a:prstGeom prst="ellipse">
-            <a:avLst/>
-          </a:prstGeom>
-          <a:solidFill>
-            <a:srgbClr val="1E2761"/>
-          </a:solidFill>
-          <a:ln w="12700">
-            <a:solidFill>
-              <a:srgbClr val="1E2761"/>
-            </a:solidFill>
-            <a:prstDash val="solid"/>
-          </a:ln>
-        </p:spPr>
-      </p:sp>
-      <p:sp>
-        <p:nvSpPr>
-          <p:cNvPr id="14" name="Text 12"/>
-          <p:cNvSpPr/>
-          <p:nvPr/>
-        </p:nvSpPr>
-        <p:spPr>
-          <a:xfrm>
-            <a:off x="1051560" y="3511296"/>
-            <a:ext cx="384048" cy="384048"/>
-          </a:xfrm>
-          <a:prstGeom prst="rect">
-            <a:avLst/>
-          </a:prstGeom>
-          <a:noFill/>
-          <a:ln/>
-        </p:spPr>
-        <p:txBody>
-          <a:bodyPr wrap="square" lIns="0" tIns="0" rIns="0" bIns="0" rtlCol="0" anchor="ctr"/>
-          <a:lstStyle/>
-          <a:p>
-            <a:pPr algn="ctr" indent="0" marL="0">
-              <a:buNone/>
-            </a:pPr>
-            <a:r>
-              <a:rPr lang="en-US" sz="1300" b="1" dirty="0">
-                <a:solidFill>
-                  <a:srgbClr val="FFFFFF"/>
-                </a:solidFill>
-                <a:latin typeface="Cambria" pitchFamily="34" charset="0"/>
-                <a:ea typeface="Cambria" pitchFamily="34" charset="-122"/>
-                <a:cs typeface="Cambria" pitchFamily="34" charset="-120"/>
-              </a:rPr>
-              <a:t>3</a:t>
-            </a:r>
-            <a:endParaRPr lang="en-US" sz="1300" dirty="0"/>
-          </a:p>
-        </p:txBody>
-      </p:sp>
-      <p:sp>
-        <p:nvSpPr>
-          <p:cNvPr id="15" name="Text 13"/>
-          <p:cNvSpPr/>
-          <p:nvPr/>
-        </p:nvSpPr>
-        <p:spPr>
-          <a:xfrm>
-            <a:off x="1600200" y="3465576"/>
-            <a:ext cx="6309360" cy="777240"/>
-          </a:xfrm>
-          <a:prstGeom prst="rect">
-            <a:avLst/>
-          </a:prstGeom>
-          <a:noFill/>
-          <a:ln/>
-        </p:spPr>
-        <p:txBody>
-          <a:bodyPr wrap="square" lIns="0" tIns="0" rIns="0" bIns="0" rtlCol="0" anchor="t"/>
-          <a:lstStyle/>
-          <a:p>
-            <a:pPr indent="0" marL="0">
-              <a:buNone/>
-            </a:pPr>
-            <a:r>
-              <a:rPr lang="en-US" sz="1350" dirty="0">
-                <a:solidFill>
-                  <a:srgbClr val="26303B"/>
-                </a:solidFill>
-                <a:latin typeface="Calibri" pitchFamily="34" charset="0"/>
-                <a:ea typeface="Calibri" pitchFamily="34" charset="-122"/>
-                <a:cs typeface="Calibri" pitchFamily="34" charset="-120"/>
-              </a:rPr>
-              <a:t>Classificate ogni caso con la piramide dell'AI Act: vietato / alto rischio / limitato / minimo</a:t>
-            </a:r>
-            <a:endParaRPr lang="en-US" sz="1350" dirty="0"/>
-          </a:p>
-        </p:txBody>
-      </p:sp>
-      <p:sp>
-        <p:nvSpPr>
-          <p:cNvPr id="16" name="Shape 14"/>
-          <p:cNvSpPr/>
-          <p:nvPr/>
-        </p:nvSpPr>
-        <p:spPr>
-          <a:xfrm>
-            <a:off x="1051560" y="4352544"/>
-            <a:ext cx="384048" cy="384048"/>
-          </a:xfrm>
-          <a:prstGeom prst="ellipse">
-            <a:avLst/>
-          </a:prstGeom>
-          <a:solidFill>
-            <a:srgbClr val="1E2761"/>
-          </a:solidFill>
-          <a:ln w="12700">
-            <a:solidFill>
-              <a:srgbClr val="1E2761"/>
-            </a:solidFill>
-            <a:prstDash val="solid"/>
-          </a:ln>
-        </p:spPr>
-      </p:sp>
-      <p:sp>
-        <p:nvSpPr>
-          <p:cNvPr id="17" name="Text 15"/>
-          <p:cNvSpPr/>
-          <p:nvPr/>
-        </p:nvSpPr>
-        <p:spPr>
-          <a:xfrm>
-            <a:off x="1051560" y="4352544"/>
-            <a:ext cx="384048" cy="384048"/>
-          </a:xfrm>
-          <a:prstGeom prst="rect">
-            <a:avLst/>
-          </a:prstGeom>
-          <a:noFill/>
-          <a:ln/>
-        </p:spPr>
-        <p:txBody>
-          <a:bodyPr wrap="square" lIns="0" tIns="0" rIns="0" bIns="0" rtlCol="0" anchor="ctr"/>
-          <a:lstStyle/>
-          <a:p>
-            <a:pPr algn="ctr" indent="0" marL="0">
-              <a:buNone/>
-            </a:pPr>
-            <a:r>
-              <a:rPr lang="en-US" sz="1300" b="1" dirty="0">
-                <a:solidFill>
-                  <a:srgbClr val="FFFFFF"/>
-                </a:solidFill>
-                <a:latin typeface="Cambria" pitchFamily="34" charset="0"/>
-                <a:ea typeface="Cambria" pitchFamily="34" charset="-122"/>
-                <a:cs typeface="Cambria" pitchFamily="34" charset="-120"/>
-              </a:rPr>
-              <a:t>4</a:t>
-            </a:r>
-            <a:endParaRPr lang="en-US" sz="1300" dirty="0"/>
-          </a:p>
-        </p:txBody>
-      </p:sp>
-      <p:sp>
-        <p:nvSpPr>
-          <p:cNvPr id="18" name="Text 16"/>
-          <p:cNvSpPr/>
-          <p:nvPr/>
-        </p:nvSpPr>
-        <p:spPr>
-          <a:xfrm>
-            <a:off x="1600200" y="4306824"/>
-            <a:ext cx="6309360" cy="777240"/>
-          </a:xfrm>
-          <a:prstGeom prst="rect">
-            <a:avLst/>
-          </a:prstGeom>
-          <a:noFill/>
-          <a:ln/>
-        </p:spPr>
-        <p:txBody>
-          <a:bodyPr wrap="square" lIns="0" tIns="0" rIns="0" bIns="0" rtlCol="0" anchor="t"/>
-          <a:lstStyle/>
-          <a:p>
-            <a:pPr indent="0" marL="0">
-              <a:buNone/>
-            </a:pPr>
-            <a:r>
-              <a:rPr lang="en-US" sz="1350" dirty="0">
-                <a:solidFill>
-                  <a:srgbClr val="26303B"/>
-                </a:solidFill>
-                <a:latin typeface="Calibri" pitchFamily="34" charset="0"/>
-                <a:ea typeface="Calibri" pitchFamily="34" charset="-122"/>
-                <a:cs typeface="Calibri" pitchFamily="34" charset="-120"/>
-              </a:rPr>
-              <a:t>Scegliete IL caso più rilevante per la vostra scuola: sarà il candidato-tema della vostra UdA di Educazione Civica</a:t>
-            </a:r>
-            <a:endParaRPr lang="en-US" sz="1350" dirty="0"/>
-          </a:p>
-        </p:txBody>
-      </p:sp>
-      <p:sp>
-        <p:nvSpPr>
-          <p:cNvPr id="19" name="Shape 17"/>
-          <p:cNvSpPr/>
-          <p:nvPr/>
-        </p:nvSpPr>
-        <p:spPr>
-          <a:xfrm>
-            <a:off x="1051560" y="5193792"/>
-            <a:ext cx="384048" cy="384048"/>
-          </a:xfrm>
-          <a:prstGeom prst="ellipse">
-            <a:avLst/>
-          </a:prstGeom>
-          <a:solidFill>
-            <a:srgbClr val="1E2761"/>
-          </a:solidFill>
-          <a:ln w="12700">
-            <a:solidFill>
-              <a:srgbClr val="1E2761"/>
-            </a:solidFill>
-            <a:prstDash val="solid"/>
-          </a:ln>
-        </p:spPr>
-      </p:sp>
-      <p:sp>
-        <p:nvSpPr>
-          <p:cNvPr id="20" name="Text 18"/>
-          <p:cNvSpPr/>
-          <p:nvPr/>
-        </p:nvSpPr>
-        <p:spPr>
-          <a:xfrm>
-            <a:off x="1051560" y="5193792"/>
-            <a:ext cx="384048" cy="384048"/>
-          </a:xfrm>
-          <a:prstGeom prst="rect">
-            <a:avLst/>
-          </a:prstGeom>
-          <a:noFill/>
-          <a:ln/>
-        </p:spPr>
-        <p:txBody>
-          <a:bodyPr wrap="square" lIns="0" tIns="0" rIns="0" bIns="0" rtlCol="0" anchor="ctr"/>
-          <a:lstStyle/>
-          <a:p>
-            <a:pPr algn="ctr" indent="0" marL="0">
-              <a:buNone/>
-            </a:pPr>
-            <a:r>
-              <a:rPr lang="en-US" sz="1300" b="1" dirty="0">
-                <a:solidFill>
-                  <a:srgbClr val="FFFFFF"/>
-                </a:solidFill>
-                <a:latin typeface="Cambria" pitchFamily="34" charset="0"/>
-                <a:ea typeface="Cambria" pitchFamily="34" charset="-122"/>
-                <a:cs typeface="Cambria" pitchFamily="34" charset="-120"/>
-              </a:rPr>
-              <a:t>5</a:t>
-            </a:r>
-            <a:endParaRPr lang="en-US" sz="1300" dirty="0"/>
-          </a:p>
-        </p:txBody>
-      </p:sp>
-      <p:sp>
-        <p:nvSpPr>
-          <p:cNvPr id="21" name="Text 19"/>
-          <p:cNvSpPr/>
-          <p:nvPr/>
-        </p:nvSpPr>
-        <p:spPr>
-          <a:xfrm>
-            <a:off x="1600200" y="5148072"/>
-            <a:ext cx="6309360" cy="777240"/>
-          </a:xfrm>
-          <a:prstGeom prst="rect">
-            <a:avLst/>
-          </a:prstGeom>
-          <a:noFill/>
-          <a:ln/>
-        </p:spPr>
-        <p:txBody>
-          <a:bodyPr wrap="square" lIns="0" tIns="0" rIns="0" bIns="0" rtlCol="0" anchor="t"/>
-          <a:lstStyle/>
-          <a:p>
-            <a:pPr indent="0" marL="0">
-              <a:buNone/>
-            </a:pPr>
-            <a:r>
-              <a:rPr lang="en-US" sz="1350" dirty="0">
-                <a:solidFill>
-                  <a:srgbClr val="26303B"/>
-                </a:solidFill>
-                <a:latin typeface="Calibri" pitchFamily="34" charset="0"/>
-                <a:ea typeface="Calibri" pitchFamily="34" charset="-122"/>
-                <a:cs typeface="Calibri" pitchFamily="34" charset="-120"/>
-              </a:rPr>
-              <a:t>Restituzione: un caso per gruppo con la classificazione (10')</a:t>
-            </a:r>
-            <a:endParaRPr lang="en-US" sz="1350" dirty="0"/>
-          </a:p>
-        </p:txBody>
-      </p:sp>
-      <p:sp>
-        <p:nvSpPr>
-          <p:cNvPr id="22" name="Shape 20"/>
-          <p:cNvSpPr/>
-          <p:nvPr/>
-        </p:nvSpPr>
-        <p:spPr>
-          <a:xfrm>
-            <a:off x="8412480" y="1600200"/>
-            <a:ext cx="3200400" cy="4572000"/>
-          </a:xfrm>
-          <a:prstGeom prst="roundRect">
-            <a:avLst>
-              <a:gd name="adj" fmla="val 2571"/>
-            </a:avLst>
-          </a:prstGeom>
-          <a:solidFill>
-            <a:srgbClr val="FFFFFF"/>
-          </a:solidFill>
-          <a:ln w="12700">
-            <a:solidFill>
-              <a:srgbClr val="FFFFFF"/>
-            </a:solidFill>
-            <a:prstDash val="solid"/>
-          </a:ln>
-        </p:spPr>
-      </p:sp>
-      <p:sp>
-        <p:nvSpPr>
-          <p:cNvPr id="23" name="Text 21"/>
-          <p:cNvSpPr/>
-          <p:nvPr/>
-        </p:nvSpPr>
-        <p:spPr>
-          <a:xfrm>
-            <a:off x="8641080" y="1764792"/>
-            <a:ext cx="2743200" cy="320040"/>
-          </a:xfrm>
-          <a:prstGeom prst="rect">
-            <a:avLst/>
-          </a:prstGeom>
-          <a:noFill/>
-          <a:ln/>
-        </p:spPr>
-        <p:txBody>
-          <a:bodyPr wrap="square" lIns="0" tIns="0" rIns="0" bIns="0" rtlCol="0" anchor="ctr"/>
-          <a:lstStyle/>
-          <a:p>
-            <a:pPr indent="0" marL="0">
-              <a:buNone/>
-            </a:pPr>
-            <a:r>
-              <a:rPr lang="en-US" sz="1450" b="1" dirty="0">
-                <a:solidFill>
-                  <a:srgbClr val="1E2761"/>
-                </a:solidFill>
-                <a:latin typeface="Cambria" pitchFamily="34" charset="0"/>
-                <a:ea typeface="Cambria" pitchFamily="34" charset="-122"/>
-                <a:cs typeface="Cambria" pitchFamily="34" charset="-120"/>
-              </a:rPr>
-              <a:t>In pratica</a:t>
-            </a:r>
-            <a:endParaRPr lang="en-US" sz="1450" dirty="0"/>
-          </a:p>
-        </p:txBody>
-      </p:sp>
-      <p:sp>
-        <p:nvSpPr>
-          <p:cNvPr id="24" name="Text 22"/>
-          <p:cNvSpPr/>
-          <p:nvPr/>
-        </p:nvSpPr>
-        <p:spPr>
-          <a:xfrm>
-            <a:off x="8641080" y="2130552"/>
-            <a:ext cx="2743200" cy="3886200"/>
-          </a:xfrm>
-          <a:prstGeom prst="rect">
-            <a:avLst/>
-          </a:prstGeom>
-          <a:noFill/>
-          <a:ln/>
-        </p:spPr>
-        <p:txBody>
-          <a:bodyPr wrap="square" lIns="0" tIns="0" rIns="0" bIns="0" rtlCol="0" anchor="t"/>
-          <a:lstStyle/>
-          <a:p>
-            <a:pPr marL="152400" indent="-152400">
+            <a:pPr marL="177800" indent="-177800">
               <a:spcAft>
-                <a:spcPts val="500"/>
+                <a:spcPts val="800"/>
               </a:spcAft>
               <a:buSzPct val="100000"/>
               <a:buChar char="•"/>
             </a:pPr>
             <a:r>
-              <a:rPr lang="en-US" sz="1250" b="1" dirty="0">
+              <a:rPr lang="en-US" sz="1500" b="1" dirty="0">
                 <a:solidFill>
                   <a:srgbClr val="26303B"/>
                 </a:solidFill>
@@ -5637,20 +5375,20 @@
                 <a:ea typeface="Calibri" pitchFamily="34" charset="-122"/>
                 <a:cs typeface="Calibri" pitchFamily="34" charset="-120"/>
               </a:rPr>
-              <a:t>45 minuti totali</a:t>
-            </a:r>
-            <a:endParaRPr lang="en-US" sz="1250" dirty="0"/>
-          </a:p>
-          <a:p>
-            <a:pPr marL="152400" indent="-152400">
+              <a:t>Floridi — viviamo 'onlife' nell'infosfera: l'etica dell'IA è un problema di design, non un freno a valle (4 principi + spiegabilità)</a:t>
+            </a:r>
+            <a:endParaRPr lang="en-US" sz="1500" dirty="0"/>
+          </a:p>
+          <a:p>
+            <a:pPr marL="177800" indent="-177800">
               <a:spcAft>
-                <a:spcPts val="500"/>
+                <a:spcPts val="800"/>
               </a:spcAft>
               <a:buSzPct val="100000"/>
               <a:buChar char="•"/>
             </a:pPr>
             <a:r>
-              <a:rPr lang="en-US" sz="1250" dirty="0">
+              <a:rPr lang="en-US" sz="1500" b="1" dirty="0">
                 <a:solidFill>
                   <a:srgbClr val="26303B"/>
                 </a:solidFill>
@@ -5658,20 +5396,20 @@
                 <a:ea typeface="Calibri" pitchFamily="34" charset="-122"/>
                 <a:cs typeface="Calibri" pitchFamily="34" charset="-120"/>
               </a:rPr>
-              <a:t>Gruppi da 3-4 in stanze</a:t>
-            </a:r>
-            <a:endParaRPr lang="en-US" sz="1250" dirty="0"/>
-          </a:p>
-          <a:p>
-            <a:pPr marL="152400" indent="-152400">
+              <a:t>Fabris — le tecnologie sono ambienti che ci trasformano: la domanda non è solo 'cosa fa la macchina' ma 'chi diventiamo noi con le macchine'</a:t>
+            </a:r>
+            <a:endParaRPr lang="en-US" sz="1500" dirty="0"/>
+          </a:p>
+          <a:p>
+            <a:pPr marL="177800" indent="-177800">
               <a:spcAft>
-                <a:spcPts val="500"/>
+                <a:spcPts val="800"/>
               </a:spcAft>
               <a:buSzPct val="100000"/>
               <a:buChar char="•"/>
             </a:pPr>
             <a:r>
-              <a:rPr lang="en-US" sz="1250" dirty="0">
+              <a:rPr lang="en-US" sz="1500" b="1" dirty="0">
                 <a:solidFill>
                   <a:srgbClr val="26303B"/>
                 </a:solidFill>
@@ -5679,20 +5417,20 @@
                 <a:ea typeface="Calibri" pitchFamily="34" charset="-122"/>
                 <a:cs typeface="Calibri" pitchFamily="34" charset="-120"/>
               </a:rPr>
-              <a:t>Scheda E1 nei Materiali operativi</a:t>
-            </a:r>
-            <a:endParaRPr lang="en-US" sz="1250" dirty="0"/>
-          </a:p>
-          <a:p>
-            <a:pPr marL="152400" indent="-152400">
+              <a:t>Benanti — l'algoretica: rendere i valori computabili, tradurli in guardrail dentro i sistemi (è ciò che farete con le policy delle UdA)</a:t>
+            </a:r>
+            <a:endParaRPr lang="en-US" sz="1500" dirty="0"/>
+          </a:p>
+          <a:p>
+            <a:pPr marL="177800" indent="-177800">
               <a:spcAft>
-                <a:spcPts val="500"/>
+                <a:spcPts val="800"/>
               </a:spcAft>
               <a:buSzPct val="100000"/>
               <a:buChar char="•"/>
             </a:pPr>
             <a:r>
-              <a:rPr lang="en-US" sz="1250" b="1" dirty="0">
+              <a:rPr lang="en-US" sz="1500" b="1" dirty="0">
                 <a:solidFill>
                   <a:srgbClr val="26303B"/>
                 </a:solidFill>
@@ -5700,9 +5438,51 @@
                 <a:ea typeface="Calibri" pitchFamily="34" charset="-122"/>
                 <a:cs typeface="Calibri" pitchFamily="34" charset="-120"/>
               </a:rPr>
-              <a:t>Il caso scelto semina la UdA del project work</a:t>
-            </a:r>
-            <a:endParaRPr lang="en-US" sz="1250" dirty="0"/>
+              <a:t>Panai — l'eticista dell'IA è ormai una professione: valutare, misurare, certificare — un mestiere che i vostri studenti potranno fare</a:t>
+            </a:r>
+            <a:endParaRPr lang="en-US" sz="1500" dirty="0"/>
+          </a:p>
+          <a:p>
+            <a:pPr marL="177800" indent="-177800">
+              <a:spcAft>
+                <a:spcPts val="800"/>
+              </a:spcAft>
+              <a:buSzPct val="100000"/>
+              <a:buChar char="•"/>
+            </a:pPr>
+            <a:r>
+              <a:rPr lang="en-US" sz="1500" dirty="0">
+                <a:solidFill>
+                  <a:srgbClr val="26303B"/>
+                </a:solidFill>
+                <a:latin typeface="Calibri" pitchFamily="34" charset="0"/>
+                <a:ea typeface="Calibri" pitchFamily="34" charset="-122"/>
+                <a:cs typeface="Calibri" pitchFamily="34" charset="-120"/>
+              </a:rPr>
+              <a:t>E il magistero: Rome Call for AI Ethics (2020, sei principi firmati anche da big tech e religioni) e la nota Antiqua et Nova (2025): l'IA è funzionalità, l'intelligenza umana è incarnata, relazionale, aperta al senso</a:t>
+            </a:r>
+            <a:endParaRPr lang="en-US" sz="1500" dirty="0"/>
+          </a:p>
+          <a:p>
+            <a:pPr marL="177800" indent="-177800">
+              <a:spcAft>
+                <a:spcPts val="800"/>
+              </a:spcAft>
+              <a:buSzPct val="100000"/>
+              <a:buChar char="•"/>
+            </a:pPr>
+            <a:r>
+              <a:rPr lang="en-US" sz="1500" dirty="0">
+                <a:solidFill>
+                  <a:srgbClr val="26303B"/>
+                </a:solidFill>
+                <a:latin typeface="Calibri" pitchFamily="34" charset="0"/>
+                <a:ea typeface="Calibri" pitchFamily="34" charset="-122"/>
+                <a:cs typeface="Calibri" pitchFamily="34" charset="-120"/>
+              </a:rPr>
+              <a:t>Leone XIV e il nome-programma: come Leone XIII davanti alla rivoluzione industriale (Rerum Novarum), la Chiesa legge l'IA come nuova questione sociale</a:t>
+            </a:r>
+            <a:endParaRPr lang="en-US" sz="1500" dirty="0"/>
           </a:p>
         </p:txBody>
       </p:sp>
@@ -5835,7 +5615,7 @@
                 <a:ea typeface="Calibri" pitchFamily="34" charset="-122"/>
                 <a:cs typeface="Calibri" pitchFamily="34" charset="-120"/>
               </a:rPr>
-              <a:t>Ethic-AI 2 — Etica, Bias e Cittadinanza nell'era dell'IA</a:t>
+              <a:t>Esercitazione — mani sulla tastiera</a:t>
             </a:r>
             <a:endParaRPr lang="en-US" sz="1100" dirty="0"/>
           </a:p>
@@ -5874,7 +5654,7 @@
                 <a:ea typeface="Cambria" pitchFamily="34" charset="-122"/>
                 <a:cs typeface="Cambria" pitchFamily="34" charset="-120"/>
               </a:rPr>
-              <a:t>Bussola internazionale 2026</a:t>
+              <a:t>Laboratorio: la mappa degli impatti</a:t>
             </a:r>
             <a:endParaRPr lang="en-US" sz="3000" dirty="0"/>
           </a:p>
@@ -5882,103 +5662,18 @@
       </p:sp>
       <p:sp>
         <p:nvSpPr>
-          <p:cNvPr id="6" name="Text 4"/>
+          <p:cNvPr id="6" name="Shape 4"/>
           <p:cNvSpPr/>
           <p:nvPr/>
         </p:nvSpPr>
         <p:spPr>
           <a:xfrm>
             <a:off x="822960" y="1600200"/>
-            <a:ext cx="6492240" cy="4754880"/>
-          </a:xfrm>
-          <a:prstGeom prst="rect">
-            <a:avLst/>
-          </a:prstGeom>
-          <a:noFill/>
-          <a:ln/>
-        </p:spPr>
-        <p:txBody>
-          <a:bodyPr wrap="square" lIns="0" tIns="0" rIns="0" bIns="0" rtlCol="0" anchor="t"/>
-          <a:lstStyle/>
-          <a:p>
-            <a:pPr marL="177800" indent="-177800">
-              <a:spcAft>
-                <a:spcPts val="800"/>
-              </a:spcAft>
-              <a:buSzPct val="100000"/>
-              <a:buChar char="•"/>
-            </a:pPr>
-            <a:r>
-              <a:rPr lang="en-US" sz="1500" b="1" dirty="0">
-                <a:solidFill>
-                  <a:srgbClr val="26303B"/>
-                </a:solidFill>
-                <a:latin typeface="Calibri" pitchFamily="34" charset="0"/>
-                <a:ea typeface="Calibri" pitchFamily="34" charset="-122"/>
-                <a:cs typeface="Calibri" pitchFamily="34" charset="-120"/>
-              </a:rPr>
-              <a:t>EDPS — Compass under the AI Act (2026): il Garante europeo ha mappato 100+ sistemi IA nelle istituzioni UE (GenAI dominante) — il modello di censimento che ogni organizzazione, scuola inclusa, dovrebbe imitare</a:t>
-            </a:r>
-            <a:endParaRPr lang="en-US" sz="1500" dirty="0"/>
-          </a:p>
-          <a:p>
-            <a:pPr marL="177800" indent="-177800">
-              <a:spcAft>
-                <a:spcPts val="800"/>
-              </a:spcAft>
-              <a:buSzPct val="100000"/>
-              <a:buChar char="•"/>
-            </a:pPr>
-            <a:r>
-              <a:rPr lang="en-US" sz="1500" dirty="0">
-                <a:solidFill>
-                  <a:srgbClr val="26303B"/>
-                </a:solidFill>
-                <a:latin typeface="Calibri" pitchFamily="34" charset="0"/>
-                <a:ea typeface="Calibri" pitchFamily="34" charset="-122"/>
-                <a:cs typeface="Calibri" pitchFamily="34" charset="-120"/>
-              </a:rPr>
-              <a:t>UNESCO — Transforming Higher Education (2026): approccio rigorosamente antropocentrico — educare ad «allocare attenzione e sforzo» nell'abbondanza algoritmica</a:t>
-            </a:r>
-            <a:endParaRPr lang="en-US" sz="1500" dirty="0"/>
-          </a:p>
-          <a:p>
-            <a:pPr marL="177800" indent="-177800">
-              <a:spcAft>
-                <a:spcPts val="800"/>
-              </a:spcAft>
-              <a:buSzPct val="100000"/>
-              <a:buChar char="•"/>
-            </a:pPr>
-            <a:r>
-              <a:rPr lang="en-US" sz="1500" dirty="0">
-                <a:solidFill>
-                  <a:srgbClr val="26303B"/>
-                </a:solidFill>
-                <a:latin typeface="Calibri" pitchFamily="34" charset="0"/>
-                <a:ea typeface="Calibri" pitchFamily="34" charset="-122"/>
-                <a:cs typeface="Calibri" pitchFamily="34" charset="-120"/>
-              </a:rPr>
-              <a:t>Racc. UNESCO etica IA (2021, §104): «AI should support the learning process without reducing cognitive abilities» — il criterio con cui giudicare ogni uso</a:t>
-            </a:r>
-            <a:endParaRPr lang="en-US" sz="1500" dirty="0"/>
-          </a:p>
-        </p:txBody>
-      </p:sp>
-      <p:sp>
-        <p:nvSpPr>
-          <p:cNvPr id="7" name="Shape 5"/>
-          <p:cNvSpPr/>
-          <p:nvPr/>
-        </p:nvSpPr>
-        <p:spPr>
-          <a:xfrm>
-            <a:off x="7635240" y="1600200"/>
-            <a:ext cx="3977640" cy="4480560"/>
+            <a:ext cx="7315200" cy="4572000"/>
           </a:xfrm>
           <a:prstGeom prst="roundRect">
             <a:avLst>
-              <a:gd name="adj" fmla="val 2069"/>
+              <a:gd name="adj" fmla="val 1800"/>
             </a:avLst>
           </a:prstGeom>
           <a:solidFill>
@@ -5994,14 +5689,39 @@
       </p:sp>
       <p:sp>
         <p:nvSpPr>
+          <p:cNvPr id="7" name="Shape 5"/>
+          <p:cNvSpPr/>
+          <p:nvPr/>
+        </p:nvSpPr>
+        <p:spPr>
+          <a:xfrm>
+            <a:off x="1051560" y="1828800"/>
+            <a:ext cx="384048" cy="384048"/>
+          </a:xfrm>
+          <a:prstGeom prst="ellipse">
+            <a:avLst/>
+          </a:prstGeom>
+          <a:solidFill>
+            <a:srgbClr val="1E2761"/>
+          </a:solidFill>
+          <a:ln w="12700">
+            <a:solidFill>
+              <a:srgbClr val="1E2761"/>
+            </a:solidFill>
+            <a:prstDash val="solid"/>
+          </a:ln>
+        </p:spPr>
+      </p:sp>
+      <p:sp>
+        <p:nvSpPr>
           <p:cNvPr id="8" name="Text 6"/>
           <p:cNvSpPr/>
           <p:nvPr/>
         </p:nvSpPr>
         <p:spPr>
           <a:xfrm>
-            <a:off x="7863840" y="1764792"/>
-            <a:ext cx="3520440" cy="320040"/>
+            <a:off x="1051560" y="1828800"/>
+            <a:ext cx="384048" cy="384048"/>
           </a:xfrm>
           <a:prstGeom prst="rect">
             <a:avLst/>
@@ -6013,19 +5733,536 @@
           <a:bodyPr wrap="square" lIns="0" tIns="0" rIns="0" bIns="0" rtlCol="0" anchor="ctr"/>
           <a:lstStyle/>
           <a:p>
-            <a:pPr indent="0" marL="0">
-              <a:buNone/>
-            </a:pPr>
-            <a:r>
-              <a:rPr lang="en-US" sz="1450" b="1" dirty="0">
-                <a:solidFill>
-                  <a:srgbClr val="1E2761"/>
+            <a:pPr algn="ctr" indent="0" marL="0">
+              <a:buNone/>
+            </a:pPr>
+            <a:r>
+              <a:rPr lang="en-US" sz="1300" b="1" dirty="0">
+                <a:solidFill>
+                  <a:srgbClr val="FFFFFF"/>
                 </a:solidFill>
                 <a:latin typeface="Cambria" pitchFamily="34" charset="0"/>
                 <a:ea typeface="Cambria" pitchFamily="34" charset="-122"/>
                 <a:cs typeface="Cambria" pitchFamily="34" charset="-120"/>
               </a:rPr>
-              <a:t>La bussola del corso</a:t>
+              <a:t>1</a:t>
+            </a:r>
+            <a:endParaRPr lang="en-US" sz="1300" dirty="0"/>
+          </a:p>
+        </p:txBody>
+      </p:sp>
+      <p:sp>
+        <p:nvSpPr>
+          <p:cNvPr id="9" name="Text 7"/>
+          <p:cNvSpPr/>
+          <p:nvPr/>
+        </p:nvSpPr>
+        <p:spPr>
+          <a:xfrm>
+            <a:off x="1600200" y="1783080"/>
+            <a:ext cx="6309360" cy="777240"/>
+          </a:xfrm>
+          <a:prstGeom prst="rect">
+            <a:avLst/>
+          </a:prstGeom>
+          <a:noFill/>
+          <a:ln/>
+        </p:spPr>
+        <p:txBody>
+          <a:bodyPr wrap="square" lIns="0" tIns="0" rIns="0" bIns="0" rtlCol="0" anchor="t"/>
+          <a:lstStyle/>
+          <a:p>
+            <a:pPr indent="0" marL="0">
+              <a:buNone/>
+            </a:pPr>
+            <a:r>
+              <a:rPr lang="en-US" sz="1350" dirty="0">
+                <a:solidFill>
+                  <a:srgbClr val="26303B"/>
+                </a:solidFill>
+                <a:latin typeface="Calibri" pitchFamily="34" charset="0"/>
+                <a:ea typeface="Calibri" pitchFamily="34" charset="-122"/>
+                <a:cs typeface="Calibri" pitchFamily="34" charset="-120"/>
+              </a:rPr>
+              <a:t>In gruppi di 3-4 (stanze Meet): elencate i punti in cui un algoritmo tocca OGGI la vita dei vostri studenti (social, gaming, ricerche, acquisti, futuro lavoro)</a:t>
+            </a:r>
+            <a:endParaRPr lang="en-US" sz="1350" dirty="0"/>
+          </a:p>
+        </p:txBody>
+      </p:sp>
+      <p:sp>
+        <p:nvSpPr>
+          <p:cNvPr id="10" name="Shape 8"/>
+          <p:cNvSpPr/>
+          <p:nvPr/>
+        </p:nvSpPr>
+        <p:spPr>
+          <a:xfrm>
+            <a:off x="1051560" y="2670048"/>
+            <a:ext cx="384048" cy="384048"/>
+          </a:xfrm>
+          <a:prstGeom prst="ellipse">
+            <a:avLst/>
+          </a:prstGeom>
+          <a:solidFill>
+            <a:srgbClr val="1E2761"/>
+          </a:solidFill>
+          <a:ln w="12700">
+            <a:solidFill>
+              <a:srgbClr val="1E2761"/>
+            </a:solidFill>
+            <a:prstDash val="solid"/>
+          </a:ln>
+        </p:spPr>
+      </p:sp>
+      <p:sp>
+        <p:nvSpPr>
+          <p:cNvPr id="11" name="Text 9"/>
+          <p:cNvSpPr/>
+          <p:nvPr/>
+        </p:nvSpPr>
+        <p:spPr>
+          <a:xfrm>
+            <a:off x="1051560" y="2670048"/>
+            <a:ext cx="384048" cy="384048"/>
+          </a:xfrm>
+          <a:prstGeom prst="rect">
+            <a:avLst/>
+          </a:prstGeom>
+          <a:noFill/>
+          <a:ln/>
+        </p:spPr>
+        <p:txBody>
+          <a:bodyPr wrap="square" lIns="0" tIns="0" rIns="0" bIns="0" rtlCol="0" anchor="ctr"/>
+          <a:lstStyle/>
+          <a:p>
+            <a:pPr algn="ctr" indent="0" marL="0">
+              <a:buNone/>
+            </a:pPr>
+            <a:r>
+              <a:rPr lang="en-US" sz="1300" b="1" dirty="0">
+                <a:solidFill>
+                  <a:srgbClr val="FFFFFF"/>
+                </a:solidFill>
+                <a:latin typeface="Cambria" pitchFamily="34" charset="0"/>
+                <a:ea typeface="Cambria" pitchFamily="34" charset="-122"/>
+                <a:cs typeface="Cambria" pitchFamily="34" charset="-120"/>
+              </a:rPr>
+              <a:t>2</a:t>
+            </a:r>
+            <a:endParaRPr lang="en-US" sz="1300" dirty="0"/>
+          </a:p>
+        </p:txBody>
+      </p:sp>
+      <p:sp>
+        <p:nvSpPr>
+          <p:cNvPr id="12" name="Text 10"/>
+          <p:cNvSpPr/>
+          <p:nvPr/>
+        </p:nvSpPr>
+        <p:spPr>
+          <a:xfrm>
+            <a:off x="1600200" y="2624328"/>
+            <a:ext cx="6309360" cy="777240"/>
+          </a:xfrm>
+          <a:prstGeom prst="rect">
+            <a:avLst/>
+          </a:prstGeom>
+          <a:noFill/>
+          <a:ln/>
+        </p:spPr>
+        <p:txBody>
+          <a:bodyPr wrap="square" lIns="0" tIns="0" rIns="0" bIns="0" rtlCol="0" anchor="t"/>
+          <a:lstStyle/>
+          <a:p>
+            <a:pPr indent="0" marL="0">
+              <a:buNone/>
+            </a:pPr>
+            <a:r>
+              <a:rPr lang="en-US" sz="1350" dirty="0">
+                <a:solidFill>
+                  <a:srgbClr val="26303B"/>
+                </a:solidFill>
+                <a:latin typeface="Calibri" pitchFamily="34" charset="0"/>
+                <a:ea typeface="Calibri" pitchFamily="34" charset="-122"/>
+                <a:cs typeface="Calibri" pitchFamily="34" charset="-120"/>
+              </a:rPr>
+              <a:t>Per ciascun punto: chi decide cosa? Con quali dati? Lo studente lo sa?</a:t>
+            </a:r>
+            <a:endParaRPr lang="en-US" sz="1350" dirty="0"/>
+          </a:p>
+        </p:txBody>
+      </p:sp>
+      <p:sp>
+        <p:nvSpPr>
+          <p:cNvPr id="13" name="Shape 11"/>
+          <p:cNvSpPr/>
+          <p:nvPr/>
+        </p:nvSpPr>
+        <p:spPr>
+          <a:xfrm>
+            <a:off x="1051560" y="3511296"/>
+            <a:ext cx="384048" cy="384048"/>
+          </a:xfrm>
+          <a:prstGeom prst="ellipse">
+            <a:avLst/>
+          </a:prstGeom>
+          <a:solidFill>
+            <a:srgbClr val="1E2761"/>
+          </a:solidFill>
+          <a:ln w="12700">
+            <a:solidFill>
+              <a:srgbClr val="1E2761"/>
+            </a:solidFill>
+            <a:prstDash val="solid"/>
+          </a:ln>
+        </p:spPr>
+      </p:sp>
+      <p:sp>
+        <p:nvSpPr>
+          <p:cNvPr id="14" name="Text 12"/>
+          <p:cNvSpPr/>
+          <p:nvPr/>
+        </p:nvSpPr>
+        <p:spPr>
+          <a:xfrm>
+            <a:off x="1051560" y="3511296"/>
+            <a:ext cx="384048" cy="384048"/>
+          </a:xfrm>
+          <a:prstGeom prst="rect">
+            <a:avLst/>
+          </a:prstGeom>
+          <a:noFill/>
+          <a:ln/>
+        </p:spPr>
+        <p:txBody>
+          <a:bodyPr wrap="square" lIns="0" tIns="0" rIns="0" bIns="0" rtlCol="0" anchor="ctr"/>
+          <a:lstStyle/>
+          <a:p>
+            <a:pPr algn="ctr" indent="0" marL="0">
+              <a:buNone/>
+            </a:pPr>
+            <a:r>
+              <a:rPr lang="en-US" sz="1300" b="1" dirty="0">
+                <a:solidFill>
+                  <a:srgbClr val="FFFFFF"/>
+                </a:solidFill>
+                <a:latin typeface="Cambria" pitchFamily="34" charset="0"/>
+                <a:ea typeface="Cambria" pitchFamily="34" charset="-122"/>
+                <a:cs typeface="Cambria" pitchFamily="34" charset="-120"/>
+              </a:rPr>
+              <a:t>3</a:t>
+            </a:r>
+            <a:endParaRPr lang="en-US" sz="1300" dirty="0"/>
+          </a:p>
+        </p:txBody>
+      </p:sp>
+      <p:sp>
+        <p:nvSpPr>
+          <p:cNvPr id="15" name="Text 13"/>
+          <p:cNvSpPr/>
+          <p:nvPr/>
+        </p:nvSpPr>
+        <p:spPr>
+          <a:xfrm>
+            <a:off x="1600200" y="3465576"/>
+            <a:ext cx="6309360" cy="777240"/>
+          </a:xfrm>
+          <a:prstGeom prst="rect">
+            <a:avLst/>
+          </a:prstGeom>
+          <a:noFill/>
+          <a:ln/>
+        </p:spPr>
+        <p:txBody>
+          <a:bodyPr wrap="square" lIns="0" tIns="0" rIns="0" bIns="0" rtlCol="0" anchor="t"/>
+          <a:lstStyle/>
+          <a:p>
+            <a:pPr indent="0" marL="0">
+              <a:buNone/>
+            </a:pPr>
+            <a:r>
+              <a:rPr lang="en-US" sz="1350" dirty="0">
+                <a:solidFill>
+                  <a:srgbClr val="26303B"/>
+                </a:solidFill>
+                <a:latin typeface="Calibri" pitchFamily="34" charset="0"/>
+                <a:ea typeface="Calibri" pitchFamily="34" charset="-122"/>
+                <a:cs typeface="Calibri" pitchFamily="34" charset="-120"/>
+              </a:rPr>
+              <a:t>Classificate ogni caso con la piramide dell'AI Act: vietato / alto rischio / limitato / minimo</a:t>
+            </a:r>
+            <a:endParaRPr lang="en-US" sz="1350" dirty="0"/>
+          </a:p>
+        </p:txBody>
+      </p:sp>
+      <p:sp>
+        <p:nvSpPr>
+          <p:cNvPr id="16" name="Shape 14"/>
+          <p:cNvSpPr/>
+          <p:nvPr/>
+        </p:nvSpPr>
+        <p:spPr>
+          <a:xfrm>
+            <a:off x="1051560" y="4352544"/>
+            <a:ext cx="384048" cy="384048"/>
+          </a:xfrm>
+          <a:prstGeom prst="ellipse">
+            <a:avLst/>
+          </a:prstGeom>
+          <a:solidFill>
+            <a:srgbClr val="1E2761"/>
+          </a:solidFill>
+          <a:ln w="12700">
+            <a:solidFill>
+              <a:srgbClr val="1E2761"/>
+            </a:solidFill>
+            <a:prstDash val="solid"/>
+          </a:ln>
+        </p:spPr>
+      </p:sp>
+      <p:sp>
+        <p:nvSpPr>
+          <p:cNvPr id="17" name="Text 15"/>
+          <p:cNvSpPr/>
+          <p:nvPr/>
+        </p:nvSpPr>
+        <p:spPr>
+          <a:xfrm>
+            <a:off x="1051560" y="4352544"/>
+            <a:ext cx="384048" cy="384048"/>
+          </a:xfrm>
+          <a:prstGeom prst="rect">
+            <a:avLst/>
+          </a:prstGeom>
+          <a:noFill/>
+          <a:ln/>
+        </p:spPr>
+        <p:txBody>
+          <a:bodyPr wrap="square" lIns="0" tIns="0" rIns="0" bIns="0" rtlCol="0" anchor="ctr"/>
+          <a:lstStyle/>
+          <a:p>
+            <a:pPr algn="ctr" indent="0" marL="0">
+              <a:buNone/>
+            </a:pPr>
+            <a:r>
+              <a:rPr lang="en-US" sz="1300" b="1" dirty="0">
+                <a:solidFill>
+                  <a:srgbClr val="FFFFFF"/>
+                </a:solidFill>
+                <a:latin typeface="Cambria" pitchFamily="34" charset="0"/>
+                <a:ea typeface="Cambria" pitchFamily="34" charset="-122"/>
+                <a:cs typeface="Cambria" pitchFamily="34" charset="-120"/>
+              </a:rPr>
+              <a:t>4</a:t>
+            </a:r>
+            <a:endParaRPr lang="en-US" sz="1300" dirty="0"/>
+          </a:p>
+        </p:txBody>
+      </p:sp>
+      <p:sp>
+        <p:nvSpPr>
+          <p:cNvPr id="18" name="Text 16"/>
+          <p:cNvSpPr/>
+          <p:nvPr/>
+        </p:nvSpPr>
+        <p:spPr>
+          <a:xfrm>
+            <a:off x="1600200" y="4306824"/>
+            <a:ext cx="6309360" cy="777240"/>
+          </a:xfrm>
+          <a:prstGeom prst="rect">
+            <a:avLst/>
+          </a:prstGeom>
+          <a:noFill/>
+          <a:ln/>
+        </p:spPr>
+        <p:txBody>
+          <a:bodyPr wrap="square" lIns="0" tIns="0" rIns="0" bIns="0" rtlCol="0" anchor="t"/>
+          <a:lstStyle/>
+          <a:p>
+            <a:pPr indent="0" marL="0">
+              <a:buNone/>
+            </a:pPr>
+            <a:r>
+              <a:rPr lang="en-US" sz="1350" dirty="0">
+                <a:solidFill>
+                  <a:srgbClr val="26303B"/>
+                </a:solidFill>
+                <a:latin typeface="Calibri" pitchFamily="34" charset="0"/>
+                <a:ea typeface="Calibri" pitchFamily="34" charset="-122"/>
+                <a:cs typeface="Calibri" pitchFamily="34" charset="-120"/>
+              </a:rPr>
+              <a:t>Scegliete IL caso più rilevante per la vostra scuola: sarà il candidato-tema della vostra UdA di Educazione Civica</a:t>
+            </a:r>
+            <a:endParaRPr lang="en-US" sz="1350" dirty="0"/>
+          </a:p>
+        </p:txBody>
+      </p:sp>
+      <p:sp>
+        <p:nvSpPr>
+          <p:cNvPr id="19" name="Shape 17"/>
+          <p:cNvSpPr/>
+          <p:nvPr/>
+        </p:nvSpPr>
+        <p:spPr>
+          <a:xfrm>
+            <a:off x="1051560" y="5193792"/>
+            <a:ext cx="384048" cy="384048"/>
+          </a:xfrm>
+          <a:prstGeom prst="ellipse">
+            <a:avLst/>
+          </a:prstGeom>
+          <a:solidFill>
+            <a:srgbClr val="1E2761"/>
+          </a:solidFill>
+          <a:ln w="12700">
+            <a:solidFill>
+              <a:srgbClr val="1E2761"/>
+            </a:solidFill>
+            <a:prstDash val="solid"/>
+          </a:ln>
+        </p:spPr>
+      </p:sp>
+      <p:sp>
+        <p:nvSpPr>
+          <p:cNvPr id="20" name="Text 18"/>
+          <p:cNvSpPr/>
+          <p:nvPr/>
+        </p:nvSpPr>
+        <p:spPr>
+          <a:xfrm>
+            <a:off x="1051560" y="5193792"/>
+            <a:ext cx="384048" cy="384048"/>
+          </a:xfrm>
+          <a:prstGeom prst="rect">
+            <a:avLst/>
+          </a:prstGeom>
+          <a:noFill/>
+          <a:ln/>
+        </p:spPr>
+        <p:txBody>
+          <a:bodyPr wrap="square" lIns="0" tIns="0" rIns="0" bIns="0" rtlCol="0" anchor="ctr"/>
+          <a:lstStyle/>
+          <a:p>
+            <a:pPr algn="ctr" indent="0" marL="0">
+              <a:buNone/>
+            </a:pPr>
+            <a:r>
+              <a:rPr lang="en-US" sz="1300" b="1" dirty="0">
+                <a:solidFill>
+                  <a:srgbClr val="FFFFFF"/>
+                </a:solidFill>
+                <a:latin typeface="Cambria" pitchFamily="34" charset="0"/>
+                <a:ea typeface="Cambria" pitchFamily="34" charset="-122"/>
+                <a:cs typeface="Cambria" pitchFamily="34" charset="-120"/>
+              </a:rPr>
+              <a:t>5</a:t>
+            </a:r>
+            <a:endParaRPr lang="en-US" sz="1300" dirty="0"/>
+          </a:p>
+        </p:txBody>
+      </p:sp>
+      <p:sp>
+        <p:nvSpPr>
+          <p:cNvPr id="21" name="Text 19"/>
+          <p:cNvSpPr/>
+          <p:nvPr/>
+        </p:nvSpPr>
+        <p:spPr>
+          <a:xfrm>
+            <a:off x="1600200" y="5148072"/>
+            <a:ext cx="6309360" cy="777240"/>
+          </a:xfrm>
+          <a:prstGeom prst="rect">
+            <a:avLst/>
+          </a:prstGeom>
+          <a:noFill/>
+          <a:ln/>
+        </p:spPr>
+        <p:txBody>
+          <a:bodyPr wrap="square" lIns="0" tIns="0" rIns="0" bIns="0" rtlCol="0" anchor="t"/>
+          <a:lstStyle/>
+          <a:p>
+            <a:pPr indent="0" marL="0">
+              <a:buNone/>
+            </a:pPr>
+            <a:r>
+              <a:rPr lang="en-US" sz="1350" dirty="0">
+                <a:solidFill>
+                  <a:srgbClr val="26303B"/>
+                </a:solidFill>
+                <a:latin typeface="Calibri" pitchFamily="34" charset="0"/>
+                <a:ea typeface="Calibri" pitchFamily="34" charset="-122"/>
+                <a:cs typeface="Calibri" pitchFamily="34" charset="-120"/>
+              </a:rPr>
+              <a:t>Restituzione: un caso per gruppo con la classificazione (10')</a:t>
+            </a:r>
+            <a:endParaRPr lang="en-US" sz="1350" dirty="0"/>
+          </a:p>
+        </p:txBody>
+      </p:sp>
+      <p:sp>
+        <p:nvSpPr>
+          <p:cNvPr id="22" name="Shape 20"/>
+          <p:cNvSpPr/>
+          <p:nvPr/>
+        </p:nvSpPr>
+        <p:spPr>
+          <a:xfrm>
+            <a:off x="8412480" y="1600200"/>
+            <a:ext cx="3200400" cy="4572000"/>
+          </a:xfrm>
+          <a:prstGeom prst="roundRect">
+            <a:avLst>
+              <a:gd name="adj" fmla="val 2571"/>
+            </a:avLst>
+          </a:prstGeom>
+          <a:solidFill>
+            <a:srgbClr val="FFFFFF"/>
+          </a:solidFill>
+          <a:ln w="12700">
+            <a:solidFill>
+              <a:srgbClr val="FFFFFF"/>
+            </a:solidFill>
+            <a:prstDash val="solid"/>
+          </a:ln>
+        </p:spPr>
+      </p:sp>
+      <p:sp>
+        <p:nvSpPr>
+          <p:cNvPr id="23" name="Text 21"/>
+          <p:cNvSpPr/>
+          <p:nvPr/>
+        </p:nvSpPr>
+        <p:spPr>
+          <a:xfrm>
+            <a:off x="8641080" y="1764792"/>
+            <a:ext cx="2743200" cy="320040"/>
+          </a:xfrm>
+          <a:prstGeom prst="rect">
+            <a:avLst/>
+          </a:prstGeom>
+          <a:noFill/>
+          <a:ln/>
+        </p:spPr>
+        <p:txBody>
+          <a:bodyPr wrap="square" lIns="0" tIns="0" rIns="0" bIns="0" rtlCol="0" anchor="ctr"/>
+          <a:lstStyle/>
+          <a:p>
+            <a:pPr indent="0" marL="0">
+              <a:buNone/>
+            </a:pPr>
+            <a:r>
+              <a:rPr lang="en-US" sz="1450" b="1" dirty="0">
+                <a:solidFill>
+                  <a:srgbClr val="1E2761"/>
+                </a:solidFill>
+                <a:latin typeface="Cambria" pitchFamily="34" charset="0"/>
+                <a:ea typeface="Cambria" pitchFamily="34" charset="-122"/>
+                <a:cs typeface="Cambria" pitchFamily="34" charset="-120"/>
+              </a:rPr>
+              <a:t>In pratica</a:t>
             </a:r>
             <a:endParaRPr lang="en-US" sz="1450" dirty="0"/>
           </a:p>
@@ -6033,14 +6270,14 @@
       </p:sp>
       <p:sp>
         <p:nvSpPr>
-          <p:cNvPr id="9" name="Text 7"/>
-          <p:cNvSpPr/>
-          <p:nvPr/>
-        </p:nvSpPr>
-        <p:spPr>
-          <a:xfrm>
-            <a:off x="7863840" y="2130552"/>
-            <a:ext cx="3520440" cy="3794760"/>
+          <p:cNvPr id="24" name="Text 22"/>
+          <p:cNvSpPr/>
+          <p:nvPr/>
+        </p:nvSpPr>
+        <p:spPr>
+          <a:xfrm>
+            <a:off x="8641080" y="2130552"/>
+            <a:ext cx="2743200" cy="3886200"/>
           </a:xfrm>
           <a:prstGeom prst="rect">
             <a:avLst/>
@@ -6060,7 +6297,7 @@
               <a:buChar char="•"/>
             </a:pPr>
             <a:r>
-              <a:rPr lang="en-US" sz="1250" dirty="0">
+              <a:rPr lang="en-US" sz="1250" b="1" dirty="0">
                 <a:solidFill>
                   <a:srgbClr val="26303B"/>
                 </a:solidFill>
@@ -6068,7 +6305,7 @@
                 <a:ea typeface="Calibri" pitchFamily="34" charset="-122"/>
                 <a:cs typeface="Calibri" pitchFamily="34" charset="-120"/>
               </a:rPr>
-              <a:t>Ogni incontro chiude con le sue ancore internazionali</a:t>
+              <a:t>45 minuti totali</a:t>
             </a:r>
             <a:endParaRPr lang="en-US" sz="1250" dirty="0"/>
           </a:p>
@@ -6089,7 +6326,7 @@
                 <a:ea typeface="Calibri" pitchFamily="34" charset="-122"/>
                 <a:cs typeface="Calibri" pitchFamily="34" charset="-120"/>
               </a:rPr>
-              <a:t>Il corso attua indirizzi UNESCO/OCSE/UE convergenti</a:t>
+              <a:t>Gruppi da 3-4 in stanze</a:t>
             </a:r>
             <a:endParaRPr lang="en-US" sz="1250" dirty="0"/>
           </a:p>
@@ -6102,6 +6339,27 @@
               <a:buChar char="•"/>
             </a:pPr>
             <a:r>
+              <a:rPr lang="en-US" sz="1250" dirty="0">
+                <a:solidFill>
+                  <a:srgbClr val="26303B"/>
+                </a:solidFill>
+                <a:latin typeface="Calibri" pitchFamily="34" charset="0"/>
+                <a:ea typeface="Calibri" pitchFamily="34" charset="-122"/>
+                <a:cs typeface="Calibri" pitchFamily="34" charset="-120"/>
+              </a:rPr>
+              <a:t>Scheda E1 nei Materiali operativi</a:t>
+            </a:r>
+            <a:endParaRPr lang="en-US" sz="1250" dirty="0"/>
+          </a:p>
+          <a:p>
+            <a:pPr marL="152400" indent="-152400">
+              <a:spcAft>
+                <a:spcPts val="500"/>
+              </a:spcAft>
+              <a:buSzPct val="100000"/>
+              <a:buChar char="•"/>
+            </a:pPr>
+            <a:r>
               <a:rPr lang="en-US" sz="1250" b="1" dirty="0">
                 <a:solidFill>
                   <a:srgbClr val="26303B"/>
@@ -6110,7 +6368,7 @@
                 <a:ea typeface="Calibri" pitchFamily="34" charset="-122"/>
                 <a:cs typeface="Calibri" pitchFamily="34" charset="-120"/>
               </a:rPr>
-              <a:t>Etica dell'IA = agenda globale, non opinione locale</a:t>
+              <a:t>Il caso scelto semina la UdA del project work</a:t>
             </a:r>
             <a:endParaRPr lang="en-US" sz="1250" dirty="0"/>
           </a:p>
@@ -6130,7 +6388,7 @@
     <p:bg>
       <p:bgPr>
         <a:solidFill>
-          <a:srgbClr val="1E2761"/>
+          <a:srgbClr val="FFFFFF"/>
         </a:solidFill>
       </p:bgPr>
     </p:bg>
@@ -6150,14 +6408,39 @@
       </p:grpSpPr>
       <p:sp>
         <p:nvSpPr>
-          <p:cNvPr id="2" name="Text 0"/>
-          <p:cNvSpPr/>
-          <p:nvPr/>
-        </p:nvSpPr>
-        <p:spPr>
-          <a:xfrm>
-            <a:off x="822960" y="731520"/>
-            <a:ext cx="10515600" cy="640080"/>
+          <p:cNvPr id="2" name="Shape 0"/>
+          <p:cNvSpPr/>
+          <p:nvPr/>
+        </p:nvSpPr>
+        <p:spPr>
+          <a:xfrm>
+            <a:off x="502920" y="384048"/>
+            <a:ext cx="566928" cy="566928"/>
+          </a:xfrm>
+          <a:prstGeom prst="ellipse">
+            <a:avLst/>
+          </a:prstGeom>
+          <a:solidFill>
+            <a:srgbClr val="1E2761"/>
+          </a:solidFill>
+          <a:ln w="12700">
+            <a:solidFill>
+              <a:srgbClr val="1E2761"/>
+            </a:solidFill>
+            <a:prstDash val="solid"/>
+          </a:ln>
+        </p:spPr>
+      </p:sp>
+      <p:sp>
+        <p:nvSpPr>
+          <p:cNvPr id="3" name="Text 1"/>
+          <p:cNvSpPr/>
+          <p:nvPr/>
+        </p:nvSpPr>
+        <p:spPr>
+          <a:xfrm>
+            <a:off x="502920" y="384048"/>
+            <a:ext cx="566928" cy="566928"/>
           </a:xfrm>
           <a:prstGeom prst="rect">
             <a:avLst/>
@@ -6169,11 +6452,11 @@
           <a:bodyPr wrap="square" lIns="0" tIns="0" rIns="0" bIns="0" rtlCol="0" anchor="ctr"/>
           <a:lstStyle/>
           <a:p>
-            <a:pPr indent="0" marL="0">
-              <a:buNone/>
-            </a:pPr>
-            <a:r>
-              <a:rPr lang="en-US" sz="3400" b="1" dirty="0">
+            <a:pPr algn="ctr" indent="0" marL="0">
+              <a:buNone/>
+            </a:pPr>
+            <a:r>
+              <a:rPr lang="en-US" sz="1800" b="1" dirty="0">
                 <a:solidFill>
                   <a:srgbClr val="FFFFFF"/>
                 </a:solidFill>
@@ -6181,22 +6464,100 @@
                 <a:ea typeface="Cambria" pitchFamily="34" charset="-122"/>
                 <a:cs typeface="Cambria" pitchFamily="34" charset="-120"/>
               </a:rPr>
-              <a:t>Per il prossimo incontro</a:t>
-            </a:r>
-            <a:endParaRPr lang="en-US" sz="3400" dirty="0"/>
-          </a:p>
-        </p:txBody>
-      </p:sp>
-      <p:sp>
-        <p:nvSpPr>
-          <p:cNvPr id="3" name="Text 1"/>
-          <p:cNvSpPr/>
-          <p:nvPr/>
-        </p:nvSpPr>
-        <p:spPr>
-          <a:xfrm>
-            <a:off x="822960" y="1645920"/>
-            <a:ext cx="10515600" cy="3108960"/>
+              <a:t>1</a:t>
+            </a:r>
+            <a:endParaRPr lang="en-US" sz="1800" dirty="0"/>
+          </a:p>
+        </p:txBody>
+      </p:sp>
+      <p:sp>
+        <p:nvSpPr>
+          <p:cNvPr id="4" name="Text 2"/>
+          <p:cNvSpPr/>
+          <p:nvPr/>
+        </p:nvSpPr>
+        <p:spPr>
+          <a:xfrm>
+            <a:off x="1234440" y="347472"/>
+            <a:ext cx="9601200" cy="274320"/>
+          </a:xfrm>
+          <a:prstGeom prst="rect">
+            <a:avLst/>
+          </a:prstGeom>
+          <a:noFill/>
+          <a:ln/>
+        </p:spPr>
+        <p:txBody>
+          <a:bodyPr wrap="square" lIns="0" tIns="0" rIns="0" bIns="0" rtlCol="0" anchor="ctr"/>
+          <a:lstStyle/>
+          <a:p>
+            <a:pPr indent="0" marL="0">
+              <a:buNone/>
+            </a:pPr>
+            <a:r>
+              <a:rPr lang="en-US" sz="1100" dirty="0">
+                <a:solidFill>
+                  <a:srgbClr val="5B6B7C"/>
+                </a:solidFill>
+                <a:latin typeface="Calibri" pitchFamily="34" charset="0"/>
+                <a:ea typeface="Calibri" pitchFamily="34" charset="-122"/>
+                <a:cs typeface="Calibri" pitchFamily="34" charset="-120"/>
+              </a:rPr>
+              <a:t>Ethic-AI 2 — Etica, Bias e Cittadinanza nell'era dell'IA</a:t>
+            </a:r>
+            <a:endParaRPr lang="en-US" sz="1100" dirty="0"/>
+          </a:p>
+        </p:txBody>
+      </p:sp>
+      <p:sp>
+        <p:nvSpPr>
+          <p:cNvPr id="5" name="Text 3"/>
+          <p:cNvSpPr/>
+          <p:nvPr/>
+        </p:nvSpPr>
+        <p:spPr>
+          <a:xfrm>
+            <a:off x="1234440" y="566928"/>
+            <a:ext cx="10332720" cy="685800"/>
+          </a:xfrm>
+          <a:prstGeom prst="rect">
+            <a:avLst/>
+          </a:prstGeom>
+          <a:noFill/>
+          <a:ln/>
+        </p:spPr>
+        <p:txBody>
+          <a:bodyPr wrap="square" lIns="0" tIns="0" rIns="0" bIns="0" rtlCol="0" anchor="ctr"/>
+          <a:lstStyle/>
+          <a:p>
+            <a:pPr indent="0" marL="0">
+              <a:buNone/>
+            </a:pPr>
+            <a:r>
+              <a:rPr lang="en-US" sz="3000" b="1" dirty="0">
+                <a:solidFill>
+                  <a:srgbClr val="1E2761"/>
+                </a:solidFill>
+                <a:latin typeface="Cambria" pitchFamily="34" charset="0"/>
+                <a:ea typeface="Cambria" pitchFamily="34" charset="-122"/>
+                <a:cs typeface="Cambria" pitchFamily="34" charset="-120"/>
+              </a:rPr>
+              <a:t>Bussola internazionale 2026</a:t>
+            </a:r>
+            <a:endParaRPr lang="en-US" sz="3000" dirty="0"/>
+          </a:p>
+        </p:txBody>
+      </p:sp>
+      <p:sp>
+        <p:nvSpPr>
+          <p:cNvPr id="6" name="Text 4"/>
+          <p:cNvSpPr/>
+          <p:nvPr/>
+        </p:nvSpPr>
+        <p:spPr>
+          <a:xfrm>
+            <a:off x="822960" y="1600200"/>
+            <a:ext cx="6492240" cy="4754880"/>
           </a:xfrm>
           <a:prstGeom prst="rect">
             <a:avLst/>
@@ -6210,156 +6571,164 @@
           <a:p>
             <a:pPr marL="177800" indent="-177800">
               <a:spcAft>
-                <a:spcPts val="1000"/>
+                <a:spcPts val="800"/>
               </a:spcAft>
               <a:buSzPct val="100000"/>
               <a:buChar char="•"/>
             </a:pPr>
             <a:r>
-              <a:rPr lang="en-US" sz="1600" dirty="0">
-                <a:solidFill>
-                  <a:srgbClr val="FFFFFF"/>
-                </a:solidFill>
-                <a:latin typeface="Calibri" pitchFamily="34" charset="0"/>
-                <a:ea typeface="Calibri" pitchFamily="34" charset="-122"/>
-                <a:cs typeface="Calibri" pitchFamily="34" charset="-120"/>
-              </a:rPr>
-              <a:t>Compilare il modulo dati partecipanti (indicatori PNRR — 5 minuti, in aula)</a:t>
-            </a:r>
-            <a:endParaRPr lang="en-US" sz="1600" dirty="0"/>
+              <a:rPr lang="en-US" sz="1500" b="1" dirty="0">
+                <a:solidFill>
+                  <a:srgbClr val="26303B"/>
+                </a:solidFill>
+                <a:latin typeface="Calibri" pitchFamily="34" charset="0"/>
+                <a:ea typeface="Calibri" pitchFamily="34" charset="-122"/>
+                <a:cs typeface="Calibri" pitchFamily="34" charset="-120"/>
+              </a:rPr>
+              <a:t>EDPS — Compass under the AI Act (2026): il Garante europeo ha mappato 100+ sistemi IA nelle istituzioni UE (GenAI dominante) — il modello di censimento che ogni organizzazione, scuola inclusa, dovrebbe imitare</a:t>
+            </a:r>
+            <a:endParaRPr lang="en-US" sz="1500" dirty="0"/>
           </a:p>
           <a:p>
             <a:pPr marL="177800" indent="-177800">
               <a:spcAft>
-                <a:spcPts val="1000"/>
+                <a:spcPts val="800"/>
               </a:spcAft>
               <a:buSzPct val="100000"/>
               <a:buChar char="•"/>
             </a:pPr>
             <a:r>
-              <a:rPr lang="en-US" sz="1600" dirty="0">
-                <a:solidFill>
-                  <a:srgbClr val="FFFFFF"/>
-                </a:solidFill>
-                <a:latin typeface="Calibri" pitchFamily="34" charset="0"/>
-                <a:ea typeface="Calibri" pitchFamily="34" charset="-122"/>
-                <a:cs typeface="Calibri" pitchFamily="34" charset="-120"/>
-              </a:rPr>
-              <a:t>Portare giovedì: un caso di decisione algoritmica trovato sui media (articolo, video, post) — lo useremo su DigComp 3.0</a:t>
-            </a:r>
-            <a:endParaRPr lang="en-US" sz="1600" dirty="0"/>
+              <a:rPr lang="en-US" sz="1500" dirty="0">
+                <a:solidFill>
+                  <a:srgbClr val="26303B"/>
+                </a:solidFill>
+                <a:latin typeface="Calibri" pitchFamily="34" charset="0"/>
+                <a:ea typeface="Calibri" pitchFamily="34" charset="-122"/>
+                <a:cs typeface="Calibri" pitchFamily="34" charset="-120"/>
+              </a:rPr>
+              <a:t>UNESCO — Transforming Higher Education (2026): approccio rigorosamente antropocentrico — educare ad «allocare attenzione e sforzo» nell'abbondanza algoritmica</a:t>
+            </a:r>
+            <a:endParaRPr lang="en-US" sz="1500" dirty="0"/>
           </a:p>
           <a:p>
             <a:pPr marL="177800" indent="-177800">
               <a:spcAft>
-                <a:spcPts val="1000"/>
+                <a:spcPts val="800"/>
               </a:spcAft>
               <a:buSzPct val="100000"/>
               <a:buChar char="•"/>
             </a:pPr>
             <a:r>
-              <a:rPr lang="en-US" sz="1600" dirty="0">
-                <a:solidFill>
-                  <a:srgbClr val="FFFFFF"/>
-                </a:solidFill>
-                <a:latin typeface="Calibri" pitchFamily="34" charset="0"/>
-                <a:ea typeface="Calibri" pitchFamily="34" charset="-122"/>
-                <a:cs typeface="Calibri" pitchFamily="34" charset="-120"/>
-              </a:rPr>
-              <a:t>Facoltativo: primi capitoli di O'Neil, 'Armi di distruzione matematica' (i casi si leggono come racconti)</a:t>
-            </a:r>
-            <a:endParaRPr lang="en-US" sz="1600" dirty="0"/>
-          </a:p>
-          <a:p>
-            <a:pPr marL="177800" indent="-177800">
+              <a:rPr lang="en-US" sz="1500" dirty="0">
+                <a:solidFill>
+                  <a:srgbClr val="26303B"/>
+                </a:solidFill>
+                <a:latin typeface="Calibri" pitchFamily="34" charset="0"/>
+                <a:ea typeface="Calibri" pitchFamily="34" charset="-122"/>
+                <a:cs typeface="Calibri" pitchFamily="34" charset="-120"/>
+              </a:rPr>
+              <a:t>Racc. UNESCO etica IA (2021, §104): «AI should support the learning process without reducing cognitive abilities» — il criterio con cui giudicare ogni uso</a:t>
+            </a:r>
+            <a:endParaRPr lang="en-US" sz="1500" dirty="0"/>
+          </a:p>
+        </p:txBody>
+      </p:sp>
+      <p:sp>
+        <p:nvSpPr>
+          <p:cNvPr id="7" name="Shape 5"/>
+          <p:cNvSpPr/>
+          <p:nvPr/>
+        </p:nvSpPr>
+        <p:spPr>
+          <a:xfrm>
+            <a:off x="7635240" y="1600200"/>
+            <a:ext cx="3977640" cy="4480560"/>
+          </a:xfrm>
+          <a:prstGeom prst="roundRect">
+            <a:avLst>
+              <a:gd name="adj" fmla="val 2069"/>
+            </a:avLst>
+          </a:prstGeom>
+          <a:solidFill>
+            <a:srgbClr val="E9F1FB"/>
+          </a:solidFill>
+          <a:ln w="12700">
+            <a:solidFill>
+              <a:srgbClr val="E9F1FB"/>
+            </a:solidFill>
+            <a:prstDash val="solid"/>
+          </a:ln>
+        </p:spPr>
+      </p:sp>
+      <p:sp>
+        <p:nvSpPr>
+          <p:cNvPr id="8" name="Text 6"/>
+          <p:cNvSpPr/>
+          <p:nvPr/>
+        </p:nvSpPr>
+        <p:spPr>
+          <a:xfrm>
+            <a:off x="7863840" y="1764792"/>
+            <a:ext cx="3520440" cy="320040"/>
+          </a:xfrm>
+          <a:prstGeom prst="rect">
+            <a:avLst/>
+          </a:prstGeom>
+          <a:noFill/>
+          <a:ln/>
+        </p:spPr>
+        <p:txBody>
+          <a:bodyPr wrap="square" lIns="0" tIns="0" rIns="0" bIns="0" rtlCol="0" anchor="ctr"/>
+          <a:lstStyle/>
+          <a:p>
+            <a:pPr indent="0" marL="0">
+              <a:buNone/>
+            </a:pPr>
+            <a:r>
+              <a:rPr lang="en-US" sz="1450" b="1" dirty="0">
+                <a:solidFill>
+                  <a:srgbClr val="1E2761"/>
+                </a:solidFill>
+                <a:latin typeface="Cambria" pitchFamily="34" charset="0"/>
+                <a:ea typeface="Cambria" pitchFamily="34" charset="-122"/>
+                <a:cs typeface="Cambria" pitchFamily="34" charset="-120"/>
+              </a:rPr>
+              <a:t>La bussola del corso</a:t>
+            </a:r>
+            <a:endParaRPr lang="en-US" sz="1450" dirty="0"/>
+          </a:p>
+        </p:txBody>
+      </p:sp>
+      <p:sp>
+        <p:nvSpPr>
+          <p:cNvPr id="9" name="Text 7"/>
+          <p:cNvSpPr/>
+          <p:nvPr/>
+        </p:nvSpPr>
+        <p:spPr>
+          <a:xfrm>
+            <a:off x="7863840" y="2130552"/>
+            <a:ext cx="3520440" cy="3794760"/>
+          </a:xfrm>
+          <a:prstGeom prst="rect">
+            <a:avLst/>
+          </a:prstGeom>
+          <a:noFill/>
+          <a:ln/>
+        </p:spPr>
+        <p:txBody>
+          <a:bodyPr wrap="square" lIns="0" tIns="0" rIns="0" bIns="0" rtlCol="0" anchor="t"/>
+          <a:lstStyle/>
+          <a:p>
+            <a:pPr marL="152400" indent="-152400">
               <a:spcAft>
-                <a:spcPts val="1000"/>
+                <a:spcPts val="500"/>
               </a:spcAft>
               <a:buSzPct val="100000"/>
               <a:buChar char="•"/>
             </a:pPr>
             <a:r>
-              <a:rPr lang="en-US" sz="1600" dirty="0">
-                <a:solidFill>
-                  <a:srgbClr val="FFFFFF"/>
-                </a:solidFill>
-                <a:latin typeface="Calibri" pitchFamily="34" charset="0"/>
-                <a:ea typeface="Calibri" pitchFamily="34" charset="-122"/>
-                <a:cs typeface="Calibri" pitchFamily="34" charset="-120"/>
-              </a:rPr>
-              <a:t>Chi non viene da Edu-GenAI 2: guida rapida all'ambiente protetto nel Drive del corso</a:t>
-            </a:r>
-            <a:endParaRPr lang="en-US" sz="1600" dirty="0"/>
-          </a:p>
-        </p:txBody>
-      </p:sp>
-      <p:sp>
-        <p:nvSpPr>
-          <p:cNvPr id="4" name="Shape 2"/>
-          <p:cNvSpPr/>
-          <p:nvPr/>
-        </p:nvSpPr>
-        <p:spPr>
-          <a:xfrm>
-            <a:off x="822960" y="4937760"/>
-            <a:ext cx="10515600" cy="1188720"/>
-          </a:xfrm>
-          <a:prstGeom prst="roundRect">
-            <a:avLst>
-              <a:gd name="adj" fmla="val 6923"/>
-            </a:avLst>
-          </a:prstGeom>
-          <a:solidFill>
-            <a:srgbClr val="CADCFC"/>
-          </a:solidFill>
-          <a:ln w="12700">
-            <a:solidFill>
-              <a:srgbClr val="CADCFC"/>
-            </a:solidFill>
-            <a:prstDash val="solid"/>
-          </a:ln>
-        </p:spPr>
-      </p:sp>
-      <p:sp>
-        <p:nvSpPr>
-          <p:cNvPr id="5" name="Text 3"/>
-          <p:cNvSpPr/>
-          <p:nvPr/>
-        </p:nvSpPr>
-        <p:spPr>
-          <a:xfrm>
-            <a:off x="1097280" y="4937760"/>
-            <a:ext cx="9966960" cy="1188720"/>
-          </a:xfrm>
-          <a:prstGeom prst="rect">
-            <a:avLst/>
-          </a:prstGeom>
-          <a:noFill/>
-          <a:ln/>
-        </p:spPr>
-        <p:txBody>
-          <a:bodyPr wrap="square" lIns="0" tIns="0" rIns="0" bIns="0" rtlCol="0" anchor="ctr"/>
-          <a:lstStyle/>
-          <a:p>
-            <a:pPr indent="0" marL="0">
-              <a:buNone/>
-            </a:pPr>
-            <a:r>
-              <a:rPr lang="en-US" sz="1600" b="1" dirty="0">
-                <a:solidFill>
-                  <a:srgbClr val="1E2761"/>
-                </a:solidFill>
-                <a:latin typeface="Cambria" pitchFamily="34" charset="0"/>
-                <a:ea typeface="Cambria" pitchFamily="34" charset="-122"/>
-                <a:cs typeface="Cambria" pitchFamily="34" charset="-120"/>
-              </a:rPr>
-              <a:t>Incontro 2 — giovedì 1 ottobre:  </a:t>
-            </a:r>
-            <a:pPr indent="0" marL="0">
-              <a:buNone/>
-            </a:pPr>
-            <a:r>
-              <a:rPr lang="en-US" sz="1400" dirty="0">
+              <a:rPr lang="en-US" sz="1250" dirty="0">
                 <a:solidFill>
                   <a:srgbClr val="26303B"/>
                 </a:solidFill>
@@ -6367,9 +6736,51 @@
                 <a:ea typeface="Calibri" pitchFamily="34" charset="-122"/>
                 <a:cs typeface="Calibri" pitchFamily="34" charset="-120"/>
               </a:rPr>
-              <a:t>Cittadinanza democratica e DigComp 3.0: il nuovo quadro europeo, la sostenibilità del digitale e il benessere online.</a:t>
-            </a:r>
-            <a:endParaRPr lang="en-US" sz="1600" dirty="0"/>
+              <a:t>Ogni incontro chiude con le sue ancore internazionali</a:t>
+            </a:r>
+            <a:endParaRPr lang="en-US" sz="1250" dirty="0"/>
+          </a:p>
+          <a:p>
+            <a:pPr marL="152400" indent="-152400">
+              <a:spcAft>
+                <a:spcPts val="500"/>
+              </a:spcAft>
+              <a:buSzPct val="100000"/>
+              <a:buChar char="•"/>
+            </a:pPr>
+            <a:r>
+              <a:rPr lang="en-US" sz="1250" dirty="0">
+                <a:solidFill>
+                  <a:srgbClr val="26303B"/>
+                </a:solidFill>
+                <a:latin typeface="Calibri" pitchFamily="34" charset="0"/>
+                <a:ea typeface="Calibri" pitchFamily="34" charset="-122"/>
+                <a:cs typeface="Calibri" pitchFamily="34" charset="-120"/>
+              </a:rPr>
+              <a:t>Il corso attua indirizzi UNESCO/OCSE/UE convergenti</a:t>
+            </a:r>
+            <a:endParaRPr lang="en-US" sz="1250" dirty="0"/>
+          </a:p>
+          <a:p>
+            <a:pPr marL="152400" indent="-152400">
+              <a:spcAft>
+                <a:spcPts val="500"/>
+              </a:spcAft>
+              <a:buSzPct val="100000"/>
+              <a:buChar char="•"/>
+            </a:pPr>
+            <a:r>
+              <a:rPr lang="en-US" sz="1250" b="1" dirty="0">
+                <a:solidFill>
+                  <a:srgbClr val="26303B"/>
+                </a:solidFill>
+                <a:latin typeface="Calibri" pitchFamily="34" charset="0"/>
+                <a:ea typeface="Calibri" pitchFamily="34" charset="-122"/>
+                <a:cs typeface="Calibri" pitchFamily="34" charset="-120"/>
+              </a:rPr>
+              <a:t>Etica dell'IA = agenda globale, non opinione locale</a:t>
+            </a:r>
+            <a:endParaRPr lang="en-US" sz="1250" dirty="0"/>
           </a:p>
         </p:txBody>
       </p:sp>

</xml_diff>

<commit_message>
Magnifica Humanitas: integrata l'enciclica di Leone XIV nei materiali Ethic-AI 2
Aggiornati approfondimento filosofico-magisteriale (tesi, nucleo
scuola-famiglia-lavoro, par. 146 sull'igiene dell'attenzione, parallelo
Rerum Novarum 1891-2026), piano di studio della formatrice, capsule e
slide Bussola filosofica dell'incontro 1.

Co-Authored-By: Claude Fable 5 <noreply@anthropic.com>
Claude-Session: https://claude.ai/code/session_0172uWTkaEwfthdZ7KpLdiL5
</commit_message>
<xml_diff>
--- a/progetto-snodi/corsi/ethic-ai-2/incontri/E01-impatto-sociale-ai-act.pptx
+++ b/progetto-snodi/corsi/ethic-ai-2/incontri/E01-impatto-sociale-ai-act.pptx
@@ -1127,7 +1127,7 @@
           <a:p>
             <a:r>
               <a:rPr lang="en-US" dirty="0"/>
-              <a:t>La slide-mappa: ogni voce tornerà come 'capsula filosofica' da 10 minuti negli incontri successivi (Floridi qui, Fabris al 2, Antiqua et Nova al 3, Benanti al 4, Panai al 5). Precisione da tenere: NON esiste a oggi un'enciclica sull'IA — i documenti sono la nota Antiqua et Nova e il Rome Call; verificare prima del corso se nel frattempo è uscita (ed è essa stessa una lezione di fact-checking). Il registro è laico: si citano per la qualità concettuale, non per catechesi.</a:t>
+              <a:t>La slide-mappa: ogni voce tornerà come 'capsula filosofica' da 10 minuti negli incontri successivi (Floridi qui, Fabris al 2, Antiqua et Nova + §146 al 3, Benanti al 4, Panai al 5). Sull'enciclica: il parallelo 1891→2026 è la lezione di storia e cittadinanza — Leone XIII rispose alla questione operaia, Leone XIV alla questione algoritmica, firmando nel 135° anniversario esatto. Il §146 ('igiene dell'attenzione': silenzio, approfondimento, lettura, confronto misurato) tornerà all'incontro 3 accanto alla dieta informativa. Il registro resta laico: si cita per la qualità concettuale e il rilievo mondiale, non per catechesi.</a:t>
             </a:r>
             <a:endParaRPr lang="en-US" dirty="0"/>
           </a:p>
@@ -5451,7 +5451,7 @@
               <a:buChar char="•"/>
             </a:pPr>
             <a:r>
-              <a:rPr lang="en-US" sz="1500" dirty="0">
+              <a:rPr lang="en-US" sz="1500" b="1" dirty="0">
                 <a:solidFill>
                   <a:srgbClr val="26303B"/>
                 </a:solidFill>
@@ -5459,7 +5459,7 @@
                 <a:ea typeface="Calibri" pitchFamily="34" charset="-122"/>
                 <a:cs typeface="Calibri" pitchFamily="34" charset="-120"/>
               </a:rPr>
-              <a:t>E il magistero: Rome Call for AI Ethics (2020, sei principi firmati anche da big tech e religioni) e la nota Antiqua et Nova (2025): l'IA è funzionalità, l'intelligenza umana è incarnata, relazionale, aperta al senso</a:t>
+              <a:t>E il magistero: l'enciclica MAGNIFICA HUMANITAS (Leone XIV, 15 maggio 2026 — 135° anniversario esatto della Rerum Novarum): la custodia della persona umana nel tempo dell'IA. Scuola, famiglia e lavoro come luoghi decisivi; la scuola aiuta a 'costruire una coscienza' — funzione che nessuna tecnologia può sostituire</a:t>
             </a:r>
             <a:endParaRPr lang="en-US" sz="1500" dirty="0"/>
           </a:p>
@@ -5480,7 +5480,7 @@
                 <a:ea typeface="Calibri" pitchFamily="34" charset="-122"/>
                 <a:cs typeface="Calibri" pitchFamily="34" charset="-120"/>
               </a:rPr>
-              <a:t>Leone XIV e il nome-programma: come Leone XIII davanti alla rivoluzione industriale (Rerum Novarum), la Chiesa legge l'IA come nuova questione sociale</a:t>
+              <a:t>Dietro di lei: la nota Antiqua et Nova (2025 — l'IA è funzionalità, l'intelligenza umana è incarnata e relazionale) e il Rome Call for AI Ethics (2020, sei principi firmati anche da big tech e religioni)</a:t>
             </a:r>
             <a:endParaRPr lang="en-US" sz="1500" dirty="0"/>
           </a:p>

</xml_diff>